<commit_message>
ep02: add reuse and NAMES slides, extend narration to ~60s
Co-Authored-By: Claude Sonnet 5.5 <noreply@anthropic.com>
Claude-Session: https://claude.ai/code/session_013kvAHSuFRL5HFD8X6vtWqT
</commit_message>
<xml_diff>
--- a/ep02-image-container/ep02.pptx
+++ b/ep02-image-container/ep02.pptx
@@ -15,9 +15,11 @@
     <p:sldId id="263" r:id="rId9"/>
     <p:sldId id="264" r:id="rId10"/>
     <p:sldId id="265" r:id="rId11"/>
+    <p:sldId id="266" r:id="rId12"/>
+    <p:sldId id="267" r:id="rId13"/>
   </p:sldIdLst>
   <p:notesMasterIdLst>
-    <p:notesMasterId r:id="rId12"/>
+    <p:notesMasterId r:id="rId14"/>
   </p:notesMasterIdLst>
   <p:sldSz cx="5143500" cy="9144000"/>
   <p:notesSz cx="9144000" cy="5143500"/>
@@ -511,7 +513,7 @@
           <a:p>
             <a:r>
               <a:rPr lang="en-US" dirty="0"/>
-              <a:t>[0:00-0:06] 이번 시간에는 Docker의 핵심, 이미지와 컨테이너를 알아봅니다.</a:t>
+              <a:t>이번 시간에는 Docker의 핵심, 이미지와 컨테이너를 알아봅니다.</a:t>
             </a:r>
             <a:endParaRPr lang="en-US" dirty="0"/>
           </a:p>
@@ -599,7 +601,7 @@
           <a:p>
             <a:r>
               <a:rPr lang="en-US" dirty="0"/>
-              <a:t>[0:57-1:00] 다음 시간에는 컨테이너를 켜고 끄는 방법을 알아봅니다.</a:t>
+              <a:t>같은 이미지로 컨테이너를 여러 개 실행할 수도 있습니다. (일부 열 생략)</a:t>
             </a:r>
             <a:endParaRPr lang="en-US" dirty="0"/>
           </a:p>
@@ -623,6 +625,182 @@
             <a:fld id="{F7021451-1387-4CA6-816F-3879F97B5CBC}" type="slidenum">
               <a:rPr lang="en-US"/>
               <a:t>10</a:t>
+            </a:fld>
+            <a:endParaRPr lang="en-US"/>
+          </a:p>
+        </p:txBody>
+      </p:sp>
+    </p:spTree>
+    <p:extLst>
+      <p:ext uri="{BB962C8B-B14F-4D97-AF65-F5344CB8AC3E}">
+        <p14:creationId xmlns:p14="http://schemas.microsoft.com/office/powerpoint/2010/main" val="1024086991"/>
+      </p:ext>
+    </p:extLst>
+  </p:cSld>
+  <p:clrMapOvr>
+    <a:masterClrMapping/>
+  </p:clrMapOvr>
+</p:notes>
+</file>
+
+<file path=ppt/notesSlides/notesSlide11.xml><?xml version="1.0" encoding="utf-8"?>
+<p:notes xmlns:a="http://schemas.openxmlformats.org/drawingml/2006/main" xmlns:r="http://schemas.openxmlformats.org/officeDocument/2006/relationships" xmlns:p="http://schemas.openxmlformats.org/presentationml/2006/main">
+  <p:cSld>
+    <p:spTree>
+      <p:nvGrpSpPr>
+        <p:cNvPr id="1" name=""/>
+        <p:cNvGrpSpPr/>
+        <p:nvPr/>
+      </p:nvGrpSpPr>
+      <p:grpSpPr>
+        <a:xfrm>
+          <a:off x="0" y="0"/>
+          <a:ext cx="0" cy="0"/>
+          <a:chOff x="0" y="0"/>
+          <a:chExt cx="0" cy="0"/>
+        </a:xfrm>
+      </p:grpSpPr>
+      <p:sp>
+        <p:nvSpPr>
+          <p:cNvPr id="2" name="Slide Image Placeholder 1"/>
+          <p:cNvSpPr>
+            <a:spLocks noGrp="1" noRot="1" noChangeAspect="1"/>
+          </p:cNvSpPr>
+          <p:nvPr>
+            <p:ph type="sldImg"/>
+          </p:nvPr>
+        </p:nvSpPr>
+        <p:spPr/>
+      </p:sp>
+      <p:sp>
+        <p:nvSpPr>
+          <p:cNvPr id="3" name="Notes Placeholder 2"/>
+          <p:cNvSpPr>
+            <a:spLocks noGrp="1"/>
+          </p:cNvSpPr>
+          <p:nvPr>
+            <p:ph type="body" idx="1"/>
+          </p:nvPr>
+        </p:nvSpPr>
+        <p:spPr/>
+        <p:txBody>
+          <a:bodyPr/>
+          <a:lstStyle/>
+          <a:p>
+            <a:r>
+              <a:rPr lang="en-US" dirty="0"/>
+              <a:t>정리합니다. pull로 받고, images로 확인하고, run으로 실행하고, ps로 확인합니다.</a:t>
+            </a:r>
+            <a:endParaRPr lang="en-US" dirty="0"/>
+          </a:p>
+        </p:txBody>
+      </p:sp>
+      <p:sp>
+        <p:nvSpPr>
+          <p:cNvPr id="4" name="Slide Number Placeholder 3"/>
+          <p:cNvSpPr>
+            <a:spLocks noGrp="1"/>
+          </p:cNvSpPr>
+          <p:nvPr>
+            <p:ph type="sldNum" sz="quarter" idx="10"/>
+          </p:nvPr>
+        </p:nvSpPr>
+        <p:spPr/>
+        <p:txBody>
+          <a:bodyPr/>
+          <a:lstStyle/>
+          <a:p>
+            <a:fld id="{F7021451-1387-4CA6-816F-3879F97B5CBC}" type="slidenum">
+              <a:rPr lang="en-US"/>
+              <a:t>11</a:t>
+            </a:fld>
+            <a:endParaRPr lang="en-US"/>
+          </a:p>
+        </p:txBody>
+      </p:sp>
+    </p:spTree>
+    <p:extLst>
+      <p:ext uri="{BB962C8B-B14F-4D97-AF65-F5344CB8AC3E}">
+        <p14:creationId xmlns:p14="http://schemas.microsoft.com/office/powerpoint/2010/main" val="1024086991"/>
+      </p:ext>
+    </p:extLst>
+  </p:cSld>
+  <p:clrMapOvr>
+    <a:masterClrMapping/>
+  </p:clrMapOvr>
+</p:notes>
+</file>
+
+<file path=ppt/notesSlides/notesSlide12.xml><?xml version="1.0" encoding="utf-8"?>
+<p:notes xmlns:a="http://schemas.openxmlformats.org/drawingml/2006/main" xmlns:r="http://schemas.openxmlformats.org/officeDocument/2006/relationships" xmlns:p="http://schemas.openxmlformats.org/presentationml/2006/main">
+  <p:cSld>
+    <p:spTree>
+      <p:nvGrpSpPr>
+        <p:cNvPr id="1" name=""/>
+        <p:cNvGrpSpPr/>
+        <p:nvPr/>
+      </p:nvGrpSpPr>
+      <p:grpSpPr>
+        <a:xfrm>
+          <a:off x="0" y="0"/>
+          <a:ext cx="0" cy="0"/>
+          <a:chOff x="0" y="0"/>
+          <a:chExt cx="0" cy="0"/>
+        </a:xfrm>
+      </p:grpSpPr>
+      <p:sp>
+        <p:nvSpPr>
+          <p:cNvPr id="2" name="Slide Image Placeholder 1"/>
+          <p:cNvSpPr>
+            <a:spLocks noGrp="1" noRot="1" noChangeAspect="1"/>
+          </p:cNvSpPr>
+          <p:nvPr>
+            <p:ph type="sldImg"/>
+          </p:nvPr>
+        </p:nvSpPr>
+        <p:spPr/>
+      </p:sp>
+      <p:sp>
+        <p:nvSpPr>
+          <p:cNvPr id="3" name="Notes Placeholder 2"/>
+          <p:cNvSpPr>
+            <a:spLocks noGrp="1"/>
+          </p:cNvSpPr>
+          <p:nvPr>
+            <p:ph type="body" idx="1"/>
+          </p:nvPr>
+        </p:nvSpPr>
+        <p:spPr/>
+        <p:txBody>
+          <a:bodyPr/>
+          <a:lstStyle/>
+          <a:p>
+            <a:r>
+              <a:rPr lang="en-US" dirty="0"/>
+              <a:t>다음 시간에는 컨테이너를 켜고 끄는 방법을 알아봅니다.</a:t>
+            </a:r>
+            <a:endParaRPr lang="en-US" dirty="0"/>
+          </a:p>
+        </p:txBody>
+      </p:sp>
+      <p:sp>
+        <p:nvSpPr>
+          <p:cNvPr id="4" name="Slide Number Placeholder 3"/>
+          <p:cNvSpPr>
+            <a:spLocks noGrp="1"/>
+          </p:cNvSpPr>
+          <p:nvPr>
+            <p:ph type="sldNum" sz="quarter" idx="10"/>
+          </p:nvPr>
+        </p:nvSpPr>
+        <p:spPr/>
+        <p:txBody>
+          <a:bodyPr/>
+          <a:lstStyle/>
+          <a:p>
+            <a:fld id="{F7021451-1387-4CA6-816F-3879F97B5CBC}" type="slidenum">
+              <a:rPr lang="en-US"/>
+              <a:t>12</a:t>
             </a:fld>
             <a:endParaRPr lang="en-US"/>
           </a:p>
@@ -687,7 +865,7 @@
           <a:p>
             <a:r>
               <a:rPr lang="en-US" dirty="0"/>
-              <a:t>[0:06-0:14] 이미지는 실행에 필요한 모든 것을 담은 설계도, 컨테이너는 그 이미지를 실행한 것입니다.</a:t>
+              <a:t>이미지는 실행에 필요한 모든 것을 담은 설계도, 컨테이너는 그 이미지를 실행한 것입니다.</a:t>
             </a:r>
             <a:endParaRPr lang="en-US" dirty="0"/>
           </a:p>
@@ -775,7 +953,7 @@
           <a:p>
             <a:r>
               <a:rPr lang="en-US" dirty="0"/>
-              <a:t>[0:14-0:20] docker pull 명령으로 Docker Hub에서 nginx 이미지를 내려받습니다.</a:t>
+              <a:t>이미지는 한 번 만들어 두면 어디서든 똑같이 실행할 수 있습니다.</a:t>
             </a:r>
             <a:endParaRPr lang="en-US" dirty="0"/>
           </a:p>
@@ -863,7 +1041,7 @@
           <a:p>
             <a:r>
               <a:rPr lang="en-US" dirty="0"/>
-              <a:t>[0:20-0:26] 마지막에 Downloaded 메시지가 나오면 내려받기가 끝난 것입니다. (화면은 긴 진행 출력의 일부만 표시)</a:t>
+              <a:t>docker pull 명령으로 Docker Hub에서 nginx 이미지를 내려받습니다.</a:t>
             </a:r>
             <a:endParaRPr lang="en-US" dirty="0"/>
           </a:p>
@@ -951,7 +1129,7 @@
           <a:p>
             <a:r>
               <a:rPr lang="en-US" dirty="0"/>
-              <a:t>[0:26-0:32] docker images로 내려받은 이미지를 확인합니다.</a:t>
+              <a:t>마지막에 Downloaded 메시지가 나오면 내려받기가 끝난 것입니다. (화면은 긴 진행 출력의 일부만 표시)</a:t>
             </a:r>
             <a:endParaRPr lang="en-US" dirty="0"/>
           </a:p>
@@ -1039,7 +1217,7 @@
           <a:p>
             <a:r>
               <a:rPr lang="en-US" dirty="0"/>
-              <a:t>[0:32-0:40] docker run으로 이미지를 컨테이너로 실행합니다. -d는 백그라운드 실행, --name은 컨테이너 이름입니다. (컨테이너 ID는 앞부분만 표시)</a:t>
+              <a:t>docker images로 내려받은 이미지를 확인합니다.</a:t>
             </a:r>
             <a:endParaRPr lang="en-US" dirty="0"/>
           </a:p>
@@ -1127,7 +1305,7 @@
           <a:p>
             <a:r>
               <a:rPr lang="en-US" dirty="0"/>
-              <a:t>[0:40-0:46] docker ps로 실행 중인 컨테이너를 확인합니다. Up이면 실행 중입니다. (일부 열 생략)</a:t>
+              <a:t>docker run으로 이미지를 컨테이너로 실행합니다. -d는 백그라운드 실행, --name은 컨테이너 이름입니다. (컨테이너 ID는 앞부분만 표시)</a:t>
             </a:r>
             <a:endParaRPr lang="en-US" dirty="0"/>
           </a:p>
@@ -1215,7 +1393,7 @@
           <a:p>
             <a:r>
               <a:rPr lang="en-US" dirty="0"/>
-              <a:t>[0:46-0:52] 같은 이미지로 컨테이너를 여러 개 실행할 수도 있습니다. (일부 열 생략)</a:t>
+              <a:t>docker ps로 실행 중인 컨테이너를 확인합니다. Up이면 실행 중입니다. (일부 열 생략)</a:t>
             </a:r>
             <a:endParaRPr lang="en-US" dirty="0"/>
           </a:p>
@@ -1303,7 +1481,7 @@
           <a:p>
             <a:r>
               <a:rPr lang="en-US" dirty="0"/>
-              <a:t>[0:52-0:57] 정리합니다. pull로 받고, images로 확인하고, run으로 실행하고, ps로 확인합니다.</a:t>
+              <a:t>NAMES 열에서 컨테이너 이름을 확인할 수 있습니다. (일부 열 생략)</a:t>
             </a:r>
             <a:endParaRPr lang="en-US" dirty="0"/>
           </a:p>
@@ -1958,6 +2136,1154 @@
                 <a:ea typeface="맑은 고딕" pitchFamily="34" charset="-122"/>
                 <a:cs typeface="맑은 고딕" pitchFamily="34" charset="-120"/>
               </a:rPr>
+              <a:t>같은 이미지로 컨테이너를 여러 개 실행할 수도 있습니다.</a:t>
+            </a:r>
+            <a:endParaRPr lang="en-US" sz="1500" dirty="0"/>
+          </a:p>
+        </p:txBody>
+      </p:sp>
+      <p:sp>
+        <p:nvSpPr>
+          <p:cNvPr id="5" name="터미널탭"/>
+          <p:cNvSpPr/>
+          <p:nvPr/>
+        </p:nvSpPr>
+        <p:spPr>
+          <a:xfrm>
+            <a:off x="395935" y="2404872"/>
+            <a:ext cx="1542593" cy="319126"/>
+          </a:xfrm>
+          <a:prstGeom prst="roundRect">
+            <a:avLst>
+              <a:gd name="adj" fmla="val 17192"/>
+            </a:avLst>
+          </a:prstGeom>
+          <a:solidFill>
+            <a:srgbClr val="13141C"/>
+          </a:solidFill>
+          <a:ln w="9525">
+            <a:solidFill>
+              <a:srgbClr val="393B4A"/>
+            </a:solidFill>
+            <a:prstDash val="solid"/>
+          </a:ln>
+        </p:spPr>
+      </p:sp>
+      <p:sp>
+        <p:nvSpPr>
+          <p:cNvPr id="6" name="Text 3"/>
+          <p:cNvSpPr txBox="1"/>
+          <p:nvPr/>
+        </p:nvSpPr>
+        <p:spPr>
+          <a:xfrm>
+            <a:off x="395935" y="2404872"/>
+            <a:ext cx="1542593" cy="319126"/>
+          </a:xfrm>
+          <a:prstGeom prst="rect">
+            <a:avLst/>
+          </a:prstGeom>
+          <a:noFill/>
+          <a:ln/>
+        </p:spPr>
+        <p:txBody>
+          <a:bodyPr wrap="square" lIns="0" tIns="0" rIns="0" bIns="0" rtlCol="0" anchor="ctr"/>
+          <a:lstStyle/>
+          <a:p>
+            <a:pPr algn="ctr" indent="0" marL="0">
+              <a:buNone/>
+            </a:pPr>
+            <a:r>
+              <a:rPr lang="en-US" sz="1125" b="1" dirty="0">
+                <a:solidFill>
+                  <a:srgbClr val="F5F6FA"/>
+                </a:solidFill>
+                <a:latin typeface="Courier New" pitchFamily="34" charset="0"/>
+                <a:ea typeface="Courier New" pitchFamily="34" charset="-122"/>
+                <a:cs typeface="Courier New" pitchFamily="34" charset="-120"/>
+              </a:rPr>
+              <a:t>terminal</a:t>
+            </a:r>
+            <a:endParaRPr lang="en-US" sz="1125" dirty="0"/>
+          </a:p>
+        </p:txBody>
+      </p:sp>
+      <p:sp>
+        <p:nvSpPr>
+          <p:cNvPr id="7" name="터미널박스"/>
+          <p:cNvSpPr/>
+          <p:nvPr/>
+        </p:nvSpPr>
+        <p:spPr>
+          <a:xfrm>
+            <a:off x="395935" y="2827325"/>
+            <a:ext cx="4526280" cy="2124151"/>
+          </a:xfrm>
+          <a:prstGeom prst="roundRect">
+            <a:avLst>
+              <a:gd name="adj" fmla="val 3444"/>
+            </a:avLst>
+          </a:prstGeom>
+          <a:solidFill>
+            <a:srgbClr val="13141C"/>
+          </a:solidFill>
+          <a:ln w="9525">
+            <a:solidFill>
+              <a:srgbClr val="393B4A"/>
+            </a:solidFill>
+            <a:prstDash val="solid"/>
+          </a:ln>
+        </p:spPr>
+      </p:sp>
+      <p:sp>
+        <p:nvSpPr>
+          <p:cNvPr id="8" name="터미널줄1"/>
+          <p:cNvSpPr txBox="1"/>
+          <p:nvPr/>
+        </p:nvSpPr>
+        <p:spPr>
+          <a:xfrm>
+            <a:off x="523951" y="2955341"/>
+            <a:ext cx="4270248" cy="228600"/>
+          </a:xfrm>
+          <a:prstGeom prst="rect">
+            <a:avLst/>
+          </a:prstGeom>
+          <a:noFill/>
+          <a:ln/>
+        </p:spPr>
+        <p:txBody>
+          <a:bodyPr wrap="none" lIns="0" tIns="0" rIns="0" bIns="0" rtlCol="0" anchor="ctr"/>
+          <a:lstStyle/>
+          <a:p>
+            <a:pPr indent="0" marL="0">
+              <a:buNone/>
+            </a:pPr>
+            <a:r>
+              <a:rPr lang="en-US" sz="1100" b="1" dirty="0">
+                <a:solidFill>
+                  <a:srgbClr val="50FA7B"/>
+                </a:solidFill>
+                <a:latin typeface="Courier New" pitchFamily="34" charset="0"/>
+                <a:ea typeface="Courier New" pitchFamily="34" charset="-122"/>
+                <a:cs typeface="Courier New" pitchFamily="34" charset="-120"/>
+              </a:rPr>
+              <a:t>user@PC:~$ </a:t>
+            </a:r>
+            <a:pPr indent="0" marL="0">
+              <a:buNone/>
+            </a:pPr>
+            <a:r>
+              <a:rPr lang="en-US" sz="1100" dirty="0">
+                <a:solidFill>
+                  <a:srgbClr val="F5F6FA"/>
+                </a:solidFill>
+                <a:latin typeface="Courier New" pitchFamily="34" charset="0"/>
+                <a:ea typeface="Courier New" pitchFamily="34" charset="-122"/>
+                <a:cs typeface="Courier New" pitchFamily="34" charset="-120"/>
+              </a:rPr>
+              <a:t>docker run -d --name web2 nginx:alpine</a:t>
+            </a:r>
+            <a:endParaRPr lang="en-US" sz="1100" dirty="0"/>
+          </a:p>
+        </p:txBody>
+      </p:sp>
+      <p:sp>
+        <p:nvSpPr>
+          <p:cNvPr id="9" name="강조"/>
+          <p:cNvSpPr/>
+          <p:nvPr/>
+        </p:nvSpPr>
+        <p:spPr>
+          <a:xfrm>
+            <a:off x="459943" y="2946197"/>
+            <a:ext cx="4398264" cy="246888"/>
+          </a:xfrm>
+          <a:prstGeom prst="roundRect">
+            <a:avLst>
+              <a:gd name="adj" fmla="val 18519"/>
+            </a:avLst>
+          </a:prstGeom>
+          <a:solidFill>
+            <a:srgbClr val="13141C">
+              <a:alpha val="0"/>
+            </a:srgbClr>
+          </a:solidFill>
+          <a:ln w="22225">
+            <a:solidFill>
+              <a:srgbClr val="50FA7B"/>
+            </a:solidFill>
+            <a:prstDash val="solid"/>
+          </a:ln>
+        </p:spPr>
+      </p:sp>
+      <p:sp>
+        <p:nvSpPr>
+          <p:cNvPr id="10" name="터미널줄2"/>
+          <p:cNvSpPr txBox="1"/>
+          <p:nvPr/>
+        </p:nvSpPr>
+        <p:spPr>
+          <a:xfrm>
+            <a:off x="523951" y="3183941"/>
+            <a:ext cx="4270248" cy="228600"/>
+          </a:xfrm>
+          <a:prstGeom prst="rect">
+            <a:avLst/>
+          </a:prstGeom>
+          <a:noFill/>
+          <a:ln/>
+        </p:spPr>
+        <p:txBody>
+          <a:bodyPr wrap="none" lIns="0" tIns="0" rIns="0" bIns="0" rtlCol="0" anchor="ctr"/>
+          <a:lstStyle/>
+          <a:p>
+            <a:pPr indent="0" marL="0">
+              <a:buNone/>
+            </a:pPr>
+            <a:r>
+              <a:rPr lang="en-US" sz="1100" dirty="0">
+                <a:solidFill>
+                  <a:srgbClr val="F5F6FA"/>
+                </a:solidFill>
+                <a:latin typeface="Courier New" pitchFamily="34" charset="0"/>
+                <a:ea typeface="Courier New" pitchFamily="34" charset="-122"/>
+                <a:cs typeface="Courier New" pitchFamily="34" charset="-120"/>
+              </a:rPr>
+              <a:t>79e4073fcb973f64b85768bb15405ffc0b27c2b5…</a:t>
+            </a:r>
+            <a:endParaRPr lang="en-US" sz="1100" dirty="0"/>
+          </a:p>
+        </p:txBody>
+      </p:sp>
+      <p:sp>
+        <p:nvSpPr>
+          <p:cNvPr id="11" name="터미널줄3"/>
+          <p:cNvSpPr txBox="1"/>
+          <p:nvPr/>
+        </p:nvSpPr>
+        <p:spPr>
+          <a:xfrm>
+            <a:off x="523951" y="3412541"/>
+            <a:ext cx="4270248" cy="228600"/>
+          </a:xfrm>
+          <a:prstGeom prst="rect">
+            <a:avLst/>
+          </a:prstGeom>
+          <a:noFill/>
+          <a:ln/>
+        </p:spPr>
+        <p:txBody>
+          <a:bodyPr wrap="none" lIns="0" tIns="0" rIns="0" bIns="0" rtlCol="0" anchor="ctr"/>
+          <a:lstStyle/>
+          <a:p>
+            <a:pPr indent="0" marL="0">
+              <a:buNone/>
+            </a:pPr>
+            <a:r>
+              <a:rPr lang="en-US" sz="1100" b="1" dirty="0">
+                <a:solidFill>
+                  <a:srgbClr val="50FA7B"/>
+                </a:solidFill>
+                <a:latin typeface="Courier New" pitchFamily="34" charset="0"/>
+                <a:ea typeface="Courier New" pitchFamily="34" charset="-122"/>
+                <a:cs typeface="Courier New" pitchFamily="34" charset="-120"/>
+              </a:rPr>
+              <a:t>user@PC:~$ </a:t>
+            </a:r>
+            <a:pPr indent="0" marL="0">
+              <a:buNone/>
+            </a:pPr>
+            <a:r>
+              <a:rPr lang="en-US" sz="1100" dirty="0">
+                <a:solidFill>
+                  <a:srgbClr val="F5F6FA"/>
+                </a:solidFill>
+                <a:latin typeface="Courier New" pitchFamily="34" charset="0"/>
+                <a:ea typeface="Courier New" pitchFamily="34" charset="-122"/>
+                <a:cs typeface="Courier New" pitchFamily="34" charset="-120"/>
+              </a:rPr>
+              <a:t>docker ps</a:t>
+            </a:r>
+            <a:endParaRPr lang="en-US" sz="1100" dirty="0"/>
+          </a:p>
+        </p:txBody>
+      </p:sp>
+      <p:sp>
+        <p:nvSpPr>
+          <p:cNvPr id="12" name="터미널줄4"/>
+          <p:cNvSpPr txBox="1"/>
+          <p:nvPr/>
+        </p:nvSpPr>
+        <p:spPr>
+          <a:xfrm>
+            <a:off x="523951" y="3641141"/>
+            <a:ext cx="4270248" cy="228600"/>
+          </a:xfrm>
+          <a:prstGeom prst="rect">
+            <a:avLst/>
+          </a:prstGeom>
+          <a:noFill/>
+          <a:ln/>
+        </p:spPr>
+        <p:txBody>
+          <a:bodyPr wrap="none" lIns="0" tIns="0" rIns="0" bIns="0" rtlCol="0" anchor="ctr"/>
+          <a:lstStyle/>
+          <a:p>
+            <a:pPr indent="0" marL="0">
+              <a:buNone/>
+            </a:pPr>
+            <a:r>
+              <a:rPr lang="en-US" sz="1100" dirty="0">
+                <a:solidFill>
+                  <a:srgbClr val="6B7280"/>
+                </a:solidFill>
+                <a:latin typeface="Courier New" pitchFamily="34" charset="0"/>
+                <a:ea typeface="Courier New" pitchFamily="34" charset="-122"/>
+                <a:cs typeface="Courier New" pitchFamily="34" charset="-120"/>
+              </a:rPr>
+              <a:t>CONTAINER ID   IMAGE          STATUS         NAMES</a:t>
+            </a:r>
+            <a:endParaRPr lang="en-US" sz="1100" dirty="0"/>
+          </a:p>
+        </p:txBody>
+      </p:sp>
+      <p:sp>
+        <p:nvSpPr>
+          <p:cNvPr id="13" name="터미널줄5"/>
+          <p:cNvSpPr txBox="1"/>
+          <p:nvPr/>
+        </p:nvSpPr>
+        <p:spPr>
+          <a:xfrm>
+            <a:off x="523951" y="3869741"/>
+            <a:ext cx="4270248" cy="228600"/>
+          </a:xfrm>
+          <a:prstGeom prst="rect">
+            <a:avLst/>
+          </a:prstGeom>
+          <a:noFill/>
+          <a:ln/>
+        </p:spPr>
+        <p:txBody>
+          <a:bodyPr wrap="none" lIns="0" tIns="0" rIns="0" bIns="0" rtlCol="0" anchor="ctr"/>
+          <a:lstStyle/>
+          <a:p>
+            <a:pPr indent="0" marL="0">
+              <a:buNone/>
+            </a:pPr>
+            <a:r>
+              <a:rPr lang="en-US" sz="1100" dirty="0">
+                <a:solidFill>
+                  <a:srgbClr val="F5F6FA"/>
+                </a:solidFill>
+                <a:latin typeface="Courier New" pitchFamily="34" charset="0"/>
+                <a:ea typeface="Courier New" pitchFamily="34" charset="-122"/>
+                <a:cs typeface="Courier New" pitchFamily="34" charset="-120"/>
+              </a:rPr>
+              <a:t>79e4073fcb97   nginx:alpine   Up 2 seconds   web2</a:t>
+            </a:r>
+            <a:endParaRPr lang="en-US" sz="1100" dirty="0"/>
+          </a:p>
+        </p:txBody>
+      </p:sp>
+      <p:sp>
+        <p:nvSpPr>
+          <p:cNvPr id="14" name="강조"/>
+          <p:cNvSpPr/>
+          <p:nvPr/>
+        </p:nvSpPr>
+        <p:spPr>
+          <a:xfrm>
+            <a:off x="459943" y="3860597"/>
+            <a:ext cx="4398264" cy="246888"/>
+          </a:xfrm>
+          <a:prstGeom prst="roundRect">
+            <a:avLst>
+              <a:gd name="adj" fmla="val 18519"/>
+            </a:avLst>
+          </a:prstGeom>
+          <a:solidFill>
+            <a:srgbClr val="13141C">
+              <a:alpha val="0"/>
+            </a:srgbClr>
+          </a:solidFill>
+          <a:ln w="22225">
+            <a:solidFill>
+              <a:srgbClr val="50FA7B"/>
+            </a:solidFill>
+            <a:prstDash val="solid"/>
+          </a:ln>
+        </p:spPr>
+      </p:sp>
+      <p:sp>
+        <p:nvSpPr>
+          <p:cNvPr id="15" name="터미널줄6"/>
+          <p:cNvSpPr txBox="1"/>
+          <p:nvPr/>
+        </p:nvSpPr>
+        <p:spPr>
+          <a:xfrm>
+            <a:off x="523951" y="4098341"/>
+            <a:ext cx="4270248" cy="228600"/>
+          </a:xfrm>
+          <a:prstGeom prst="rect">
+            <a:avLst/>
+          </a:prstGeom>
+          <a:noFill/>
+          <a:ln/>
+        </p:spPr>
+        <p:txBody>
+          <a:bodyPr wrap="none" lIns="0" tIns="0" rIns="0" bIns="0" rtlCol="0" anchor="ctr"/>
+          <a:lstStyle/>
+          <a:p>
+            <a:pPr indent="0" marL="0">
+              <a:buNone/>
+            </a:pPr>
+            <a:r>
+              <a:rPr lang="en-US" sz="1100" dirty="0">
+                <a:solidFill>
+                  <a:srgbClr val="F5F6FA"/>
+                </a:solidFill>
+                <a:latin typeface="Courier New" pitchFamily="34" charset="0"/>
+                <a:ea typeface="Courier New" pitchFamily="34" charset="-122"/>
+                <a:cs typeface="Courier New" pitchFamily="34" charset="-120"/>
+              </a:rPr>
+              <a:t>6f360068836a   nginx:alpine   Up 5 seconds   web</a:t>
+            </a:r>
+            <a:endParaRPr lang="en-US" sz="1100" dirty="0"/>
+          </a:p>
+        </p:txBody>
+      </p:sp>
+      <p:sp>
+        <p:nvSpPr>
+          <p:cNvPr id="16" name="강조"/>
+          <p:cNvSpPr/>
+          <p:nvPr/>
+        </p:nvSpPr>
+        <p:spPr>
+          <a:xfrm>
+            <a:off x="459943" y="4089197"/>
+            <a:ext cx="4398264" cy="246888"/>
+          </a:xfrm>
+          <a:prstGeom prst="roundRect">
+            <a:avLst>
+              <a:gd name="adj" fmla="val 18519"/>
+            </a:avLst>
+          </a:prstGeom>
+          <a:solidFill>
+            <a:srgbClr val="13141C">
+              <a:alpha val="0"/>
+            </a:srgbClr>
+          </a:solidFill>
+          <a:ln w="22225">
+            <a:solidFill>
+              <a:srgbClr val="50FA7B"/>
+            </a:solidFill>
+            <a:prstDash val="solid"/>
+          </a:ln>
+        </p:spPr>
+      </p:sp>
+      <p:sp>
+        <p:nvSpPr>
+          <p:cNvPr id="17" name="설명라벨"/>
+          <p:cNvSpPr/>
+          <p:nvPr/>
+        </p:nvSpPr>
+        <p:spPr>
+          <a:xfrm>
+            <a:off x="395935" y="5157216"/>
+            <a:ext cx="4526280" cy="384048"/>
+          </a:xfrm>
+          <a:prstGeom prst="roundRect">
+            <a:avLst>
+              <a:gd name="adj" fmla="val 14286"/>
+            </a:avLst>
+          </a:prstGeom>
+          <a:solidFill>
+            <a:srgbClr val="24473A"/>
+          </a:solidFill>
+          <a:ln w="6350">
+            <a:solidFill>
+              <a:srgbClr val="24473A"/>
+            </a:solidFill>
+            <a:prstDash val="solid"/>
+          </a:ln>
+        </p:spPr>
+      </p:sp>
+      <p:sp>
+        <p:nvSpPr>
+          <p:cNvPr id="18" name="Text 15"/>
+          <p:cNvSpPr txBox="1"/>
+          <p:nvPr/>
+        </p:nvSpPr>
+        <p:spPr>
+          <a:xfrm>
+            <a:off x="395935" y="5157216"/>
+            <a:ext cx="4526280" cy="384048"/>
+          </a:xfrm>
+          <a:prstGeom prst="rect">
+            <a:avLst/>
+          </a:prstGeom>
+          <a:noFill/>
+          <a:ln/>
+        </p:spPr>
+        <p:txBody>
+          <a:bodyPr wrap="square" lIns="0" tIns="0" rIns="0" bIns="0" rtlCol="0" anchor="ctr"/>
+          <a:lstStyle/>
+          <a:p>
+            <a:pPr algn="ctr" indent="0" marL="0">
+              <a:buNone/>
+            </a:pPr>
+            <a:r>
+              <a:rPr lang="en-US" sz="1200" b="1" dirty="0">
+                <a:solidFill>
+                  <a:srgbClr val="F5F6FA"/>
+                </a:solidFill>
+                <a:latin typeface="맑은 고딕" pitchFamily="34" charset="0"/>
+                <a:ea typeface="맑은 고딕" pitchFamily="34" charset="-122"/>
+                <a:cs typeface="맑은 고딕" pitchFamily="34" charset="-120"/>
+              </a:rPr>
+              <a:t>이미지 하나, 컨테이너 둘</a:t>
+            </a:r>
+            <a:endParaRPr lang="en-US" sz="1200" dirty="0"/>
+          </a:p>
+        </p:txBody>
+      </p:sp>
+    </p:spTree>
+  </p:cSld>
+  <p:clrMapOvr>
+    <a:masterClrMapping/>
+  </p:clrMapOvr>
+</p:sld>
+</file>
+
+<file path=ppt/slides/slide11.xml><?xml version="1.0" encoding="utf-8"?>
+<p:sld xmlns:a="http://schemas.openxmlformats.org/drawingml/2006/main" xmlns:r="http://schemas.openxmlformats.org/officeDocument/2006/relationships" xmlns:p="http://schemas.openxmlformats.org/presentationml/2006/main">
+  <p:cSld name="Slide 11">
+    <p:bg>
+      <p:bgPr>
+        <a:solidFill>
+          <a:srgbClr val="1E1F29"/>
+        </a:solidFill>
+      </p:bgPr>
+    </p:bg>
+    <p:spTree>
+      <p:nvGrpSpPr>
+        <p:cNvPr id="1" name=""/>
+        <p:cNvGrpSpPr/>
+        <p:nvPr/>
+      </p:nvGrpSpPr>
+      <p:grpSpPr>
+        <a:xfrm>
+          <a:off x="0" y="0"/>
+          <a:ext cx="0" cy="0"/>
+          <a:chOff x="0" y="0"/>
+          <a:chExt cx="0" cy="0"/>
+        </a:xfrm>
+      </p:grpSpPr>
+      <p:sp>
+        <p:nvSpPr>
+          <p:cNvPr id="2" name="타이틀"/>
+          <p:cNvSpPr txBox="1"/>
+          <p:nvPr/>
+        </p:nvSpPr>
+        <p:spPr>
+          <a:xfrm>
+            <a:off x="209398" y="1158545"/>
+            <a:ext cx="4663440" cy="831190"/>
+          </a:xfrm>
+          <a:prstGeom prst="rect">
+            <a:avLst/>
+          </a:prstGeom>
+          <a:noFill/>
+          <a:ln/>
+        </p:spPr>
+        <p:txBody>
+          <a:bodyPr wrap="square" lIns="0" tIns="0" rIns="0" bIns="0" rtlCol="0" anchor="ctr"/>
+          <a:lstStyle/>
+          <a:p>
+            <a:pPr algn="l" indent="0" marL="0">
+              <a:buNone/>
+            </a:pPr>
+            <a:r>
+              <a:rPr lang="en-US" sz="2400" dirty="0">
+                <a:solidFill>
+                  <a:srgbClr val="F5F6FA"/>
+                </a:solidFill>
+                <a:latin typeface="HY견고딕" pitchFamily="34" charset="0"/>
+                <a:ea typeface="HY견고딕" pitchFamily="34" charset="-122"/>
+                <a:cs typeface="HY견고딕" pitchFamily="34" charset="-120"/>
+              </a:rPr>
+              <a:t>2회차 · 이미지와 컨테이너</a:t>
+            </a:r>
+            <a:endParaRPr lang="en-US" sz="2400" dirty="0"/>
+          </a:p>
+        </p:txBody>
+      </p:sp>
+      <p:sp>
+        <p:nvSpPr>
+          <p:cNvPr id="3" name="자막영역"/>
+          <p:cNvSpPr txBox="1"/>
+          <p:nvPr/>
+        </p:nvSpPr>
+        <p:spPr>
+          <a:xfrm>
+            <a:off x="260604" y="6012180"/>
+            <a:ext cx="4661611" cy="1252728"/>
+          </a:xfrm>
+          <a:prstGeom prst="rect">
+            <a:avLst/>
+          </a:prstGeom>
+          <a:noFill/>
+          <a:ln/>
+        </p:spPr>
+        <p:txBody>
+          <a:bodyPr wrap="square" lIns="635" tIns="635" rIns="635" bIns="635" rtlCol="0" anchor="ctr"/>
+          <a:lstStyle/>
+          <a:p>
+            <a:pPr algn="ctr" indent="0" marL="0">
+              <a:buNone/>
+            </a:pPr>
+            <a:r>
+              <a:rPr lang="en-US" sz="1500" dirty="0">
+                <a:solidFill>
+                  <a:srgbClr val="F5F6FA"/>
+                </a:solidFill>
+                <a:latin typeface="맑은 고딕" pitchFamily="34" charset="0"/>
+                <a:ea typeface="맑은 고딕" pitchFamily="34" charset="-122"/>
+                <a:cs typeface="맑은 고딕" pitchFamily="34" charset="-120"/>
+              </a:rPr>
+              <a:t>pull로 받고, images로 확인하고, run으로 실행하고, ps로 확인합니다.</a:t>
+            </a:r>
+            <a:endParaRPr lang="en-US" sz="1500" dirty="0"/>
+          </a:p>
+        </p:txBody>
+      </p:sp>
+      <p:sp>
+        <p:nvSpPr>
+          <p:cNvPr id="5" name="요약행1"/>
+          <p:cNvSpPr/>
+          <p:nvPr/>
+        </p:nvSpPr>
+        <p:spPr>
+          <a:xfrm>
+            <a:off x="411480" y="2377440"/>
+            <a:ext cx="4297680" cy="731520"/>
+          </a:xfrm>
+          <a:prstGeom prst="roundRect">
+            <a:avLst>
+              <a:gd name="adj" fmla="val 12500"/>
+            </a:avLst>
+          </a:prstGeom>
+          <a:solidFill>
+            <a:srgbClr val="13141C"/>
+          </a:solidFill>
+          <a:ln w="9525">
+            <a:solidFill>
+              <a:srgbClr val="393B4A"/>
+            </a:solidFill>
+            <a:prstDash val="solid"/>
+          </a:ln>
+        </p:spPr>
+      </p:sp>
+      <p:sp>
+        <p:nvSpPr>
+          <p:cNvPr id="6" name="Text 3"/>
+          <p:cNvSpPr txBox="1"/>
+          <p:nvPr/>
+        </p:nvSpPr>
+        <p:spPr>
+          <a:xfrm>
+            <a:off x="548640" y="2377440"/>
+            <a:ext cx="1920240" cy="731520"/>
+          </a:xfrm>
+          <a:prstGeom prst="rect">
+            <a:avLst/>
+          </a:prstGeom>
+          <a:noFill/>
+          <a:ln/>
+        </p:spPr>
+        <p:txBody>
+          <a:bodyPr wrap="square" lIns="0" tIns="0" rIns="0" bIns="0" rtlCol="0" anchor="ctr"/>
+          <a:lstStyle/>
+          <a:p>
+            <a:pPr indent="0" marL="0">
+              <a:buNone/>
+            </a:pPr>
+            <a:r>
+              <a:rPr lang="en-US" sz="1300" b="1" dirty="0">
+                <a:solidFill>
+                  <a:srgbClr val="FF79C6"/>
+                </a:solidFill>
+                <a:latin typeface="Courier New" pitchFamily="34" charset="0"/>
+                <a:ea typeface="Courier New" pitchFamily="34" charset="-122"/>
+                <a:cs typeface="Courier New" pitchFamily="34" charset="-120"/>
+              </a:rPr>
+              <a:t>docker pull</a:t>
+            </a:r>
+            <a:endParaRPr lang="en-US" sz="1300" dirty="0"/>
+          </a:p>
+        </p:txBody>
+      </p:sp>
+      <p:sp>
+        <p:nvSpPr>
+          <p:cNvPr id="7" name="Text 4"/>
+          <p:cNvSpPr txBox="1"/>
+          <p:nvPr/>
+        </p:nvSpPr>
+        <p:spPr>
+          <a:xfrm>
+            <a:off x="2423160" y="2377440"/>
+            <a:ext cx="2194560" cy="731520"/>
+          </a:xfrm>
+          <a:prstGeom prst="rect">
+            <a:avLst/>
+          </a:prstGeom>
+          <a:noFill/>
+          <a:ln/>
+        </p:spPr>
+        <p:txBody>
+          <a:bodyPr wrap="square" lIns="0" tIns="0" rIns="0" bIns="0" rtlCol="0" anchor="ctr"/>
+          <a:lstStyle/>
+          <a:p>
+            <a:pPr indent="0" marL="0">
+              <a:buNone/>
+            </a:pPr>
+            <a:r>
+              <a:rPr lang="en-US" sz="1400" dirty="0">
+                <a:solidFill>
+                  <a:srgbClr val="F5F6FA"/>
+                </a:solidFill>
+                <a:latin typeface="맑은 고딕" pitchFamily="34" charset="0"/>
+                <a:ea typeface="맑은 고딕" pitchFamily="34" charset="-122"/>
+                <a:cs typeface="맑은 고딕" pitchFamily="34" charset="-120"/>
+              </a:rPr>
+              <a:t>이미지 내려받기</a:t>
+            </a:r>
+            <a:endParaRPr lang="en-US" sz="1400" dirty="0"/>
+          </a:p>
+        </p:txBody>
+      </p:sp>
+      <p:sp>
+        <p:nvSpPr>
+          <p:cNvPr id="8" name="요약행2"/>
+          <p:cNvSpPr/>
+          <p:nvPr/>
+        </p:nvSpPr>
+        <p:spPr>
+          <a:xfrm>
+            <a:off x="411480" y="3246120"/>
+            <a:ext cx="4297680" cy="731520"/>
+          </a:xfrm>
+          <a:prstGeom prst="roundRect">
+            <a:avLst>
+              <a:gd name="adj" fmla="val 12500"/>
+            </a:avLst>
+          </a:prstGeom>
+          <a:solidFill>
+            <a:srgbClr val="13141C"/>
+          </a:solidFill>
+          <a:ln w="9525">
+            <a:solidFill>
+              <a:srgbClr val="393B4A"/>
+            </a:solidFill>
+            <a:prstDash val="solid"/>
+          </a:ln>
+        </p:spPr>
+      </p:sp>
+      <p:sp>
+        <p:nvSpPr>
+          <p:cNvPr id="9" name="Text 6"/>
+          <p:cNvSpPr txBox="1"/>
+          <p:nvPr/>
+        </p:nvSpPr>
+        <p:spPr>
+          <a:xfrm>
+            <a:off x="548640" y="3246120"/>
+            <a:ext cx="1920240" cy="731520"/>
+          </a:xfrm>
+          <a:prstGeom prst="rect">
+            <a:avLst/>
+          </a:prstGeom>
+          <a:noFill/>
+          <a:ln/>
+        </p:spPr>
+        <p:txBody>
+          <a:bodyPr wrap="square" lIns="0" tIns="0" rIns="0" bIns="0" rtlCol="0" anchor="ctr"/>
+          <a:lstStyle/>
+          <a:p>
+            <a:pPr indent="0" marL="0">
+              <a:buNone/>
+            </a:pPr>
+            <a:r>
+              <a:rPr lang="en-US" sz="1300" b="1" dirty="0">
+                <a:solidFill>
+                  <a:srgbClr val="FF79C6"/>
+                </a:solidFill>
+                <a:latin typeface="Courier New" pitchFamily="34" charset="0"/>
+                <a:ea typeface="Courier New" pitchFamily="34" charset="-122"/>
+                <a:cs typeface="Courier New" pitchFamily="34" charset="-120"/>
+              </a:rPr>
+              <a:t>docker images</a:t>
+            </a:r>
+            <a:endParaRPr lang="en-US" sz="1300" dirty="0"/>
+          </a:p>
+        </p:txBody>
+      </p:sp>
+      <p:sp>
+        <p:nvSpPr>
+          <p:cNvPr id="10" name="Text 7"/>
+          <p:cNvSpPr txBox="1"/>
+          <p:nvPr/>
+        </p:nvSpPr>
+        <p:spPr>
+          <a:xfrm>
+            <a:off x="2423160" y="3246120"/>
+            <a:ext cx="2194560" cy="731520"/>
+          </a:xfrm>
+          <a:prstGeom prst="rect">
+            <a:avLst/>
+          </a:prstGeom>
+          <a:noFill/>
+          <a:ln/>
+        </p:spPr>
+        <p:txBody>
+          <a:bodyPr wrap="square" lIns="0" tIns="0" rIns="0" bIns="0" rtlCol="0" anchor="ctr"/>
+          <a:lstStyle/>
+          <a:p>
+            <a:pPr indent="0" marL="0">
+              <a:buNone/>
+            </a:pPr>
+            <a:r>
+              <a:rPr lang="en-US" sz="1400" dirty="0">
+                <a:solidFill>
+                  <a:srgbClr val="F5F6FA"/>
+                </a:solidFill>
+                <a:latin typeface="맑은 고딕" pitchFamily="34" charset="0"/>
+                <a:ea typeface="맑은 고딕" pitchFamily="34" charset="-122"/>
+                <a:cs typeface="맑은 고딕" pitchFamily="34" charset="-120"/>
+              </a:rPr>
+              <a:t>이미지 목록 보기</a:t>
+            </a:r>
+            <a:endParaRPr lang="en-US" sz="1400" dirty="0"/>
+          </a:p>
+        </p:txBody>
+      </p:sp>
+      <p:sp>
+        <p:nvSpPr>
+          <p:cNvPr id="11" name="요약행3"/>
+          <p:cNvSpPr/>
+          <p:nvPr/>
+        </p:nvSpPr>
+        <p:spPr>
+          <a:xfrm>
+            <a:off x="411480" y="4114800"/>
+            <a:ext cx="4297680" cy="731520"/>
+          </a:xfrm>
+          <a:prstGeom prst="roundRect">
+            <a:avLst>
+              <a:gd name="adj" fmla="val 12500"/>
+            </a:avLst>
+          </a:prstGeom>
+          <a:solidFill>
+            <a:srgbClr val="13141C"/>
+          </a:solidFill>
+          <a:ln w="9525">
+            <a:solidFill>
+              <a:srgbClr val="393B4A"/>
+            </a:solidFill>
+            <a:prstDash val="solid"/>
+          </a:ln>
+        </p:spPr>
+      </p:sp>
+      <p:sp>
+        <p:nvSpPr>
+          <p:cNvPr id="12" name="Text 9"/>
+          <p:cNvSpPr txBox="1"/>
+          <p:nvPr/>
+        </p:nvSpPr>
+        <p:spPr>
+          <a:xfrm>
+            <a:off x="548640" y="4114800"/>
+            <a:ext cx="1920240" cy="731520"/>
+          </a:xfrm>
+          <a:prstGeom prst="rect">
+            <a:avLst/>
+          </a:prstGeom>
+          <a:noFill/>
+          <a:ln/>
+        </p:spPr>
+        <p:txBody>
+          <a:bodyPr wrap="square" lIns="0" tIns="0" rIns="0" bIns="0" rtlCol="0" anchor="ctr"/>
+          <a:lstStyle/>
+          <a:p>
+            <a:pPr indent="0" marL="0">
+              <a:buNone/>
+            </a:pPr>
+            <a:r>
+              <a:rPr lang="en-US" sz="1300" b="1" dirty="0">
+                <a:solidFill>
+                  <a:srgbClr val="FF79C6"/>
+                </a:solidFill>
+                <a:latin typeface="Courier New" pitchFamily="34" charset="0"/>
+                <a:ea typeface="Courier New" pitchFamily="34" charset="-122"/>
+                <a:cs typeface="Courier New" pitchFamily="34" charset="-120"/>
+              </a:rPr>
+              <a:t>docker run</a:t>
+            </a:r>
+            <a:endParaRPr lang="en-US" sz="1300" dirty="0"/>
+          </a:p>
+        </p:txBody>
+      </p:sp>
+      <p:sp>
+        <p:nvSpPr>
+          <p:cNvPr id="13" name="Text 10"/>
+          <p:cNvSpPr txBox="1"/>
+          <p:nvPr/>
+        </p:nvSpPr>
+        <p:spPr>
+          <a:xfrm>
+            <a:off x="2423160" y="4114800"/>
+            <a:ext cx="2194560" cy="731520"/>
+          </a:xfrm>
+          <a:prstGeom prst="rect">
+            <a:avLst/>
+          </a:prstGeom>
+          <a:noFill/>
+          <a:ln/>
+        </p:spPr>
+        <p:txBody>
+          <a:bodyPr wrap="square" lIns="0" tIns="0" rIns="0" bIns="0" rtlCol="0" anchor="ctr"/>
+          <a:lstStyle/>
+          <a:p>
+            <a:pPr indent="0" marL="0">
+              <a:buNone/>
+            </a:pPr>
+            <a:r>
+              <a:rPr lang="en-US" sz="1400" dirty="0">
+                <a:solidFill>
+                  <a:srgbClr val="F5F6FA"/>
+                </a:solidFill>
+                <a:latin typeface="맑은 고딕" pitchFamily="34" charset="0"/>
+                <a:ea typeface="맑은 고딕" pitchFamily="34" charset="-122"/>
+                <a:cs typeface="맑은 고딕" pitchFamily="34" charset="-120"/>
+              </a:rPr>
+              <a:t>컨테이너 실행</a:t>
+            </a:r>
+            <a:endParaRPr lang="en-US" sz="1400" dirty="0"/>
+          </a:p>
+        </p:txBody>
+      </p:sp>
+      <p:sp>
+        <p:nvSpPr>
+          <p:cNvPr id="14" name="요약행4"/>
+          <p:cNvSpPr/>
+          <p:nvPr/>
+        </p:nvSpPr>
+        <p:spPr>
+          <a:xfrm>
+            <a:off x="411480" y="4983480"/>
+            <a:ext cx="4297680" cy="731520"/>
+          </a:xfrm>
+          <a:prstGeom prst="roundRect">
+            <a:avLst>
+              <a:gd name="adj" fmla="val 12500"/>
+            </a:avLst>
+          </a:prstGeom>
+          <a:solidFill>
+            <a:srgbClr val="13141C"/>
+          </a:solidFill>
+          <a:ln w="9525">
+            <a:solidFill>
+              <a:srgbClr val="393B4A"/>
+            </a:solidFill>
+            <a:prstDash val="solid"/>
+          </a:ln>
+        </p:spPr>
+      </p:sp>
+      <p:sp>
+        <p:nvSpPr>
+          <p:cNvPr id="15" name="Text 12"/>
+          <p:cNvSpPr txBox="1"/>
+          <p:nvPr/>
+        </p:nvSpPr>
+        <p:spPr>
+          <a:xfrm>
+            <a:off x="548640" y="4983480"/>
+            <a:ext cx="1920240" cy="731520"/>
+          </a:xfrm>
+          <a:prstGeom prst="rect">
+            <a:avLst/>
+          </a:prstGeom>
+          <a:noFill/>
+          <a:ln/>
+        </p:spPr>
+        <p:txBody>
+          <a:bodyPr wrap="square" lIns="0" tIns="0" rIns="0" bIns="0" rtlCol="0" anchor="ctr"/>
+          <a:lstStyle/>
+          <a:p>
+            <a:pPr indent="0" marL="0">
+              <a:buNone/>
+            </a:pPr>
+            <a:r>
+              <a:rPr lang="en-US" sz="1300" b="1" dirty="0">
+                <a:solidFill>
+                  <a:srgbClr val="FF79C6"/>
+                </a:solidFill>
+                <a:latin typeface="Courier New" pitchFamily="34" charset="0"/>
+                <a:ea typeface="Courier New" pitchFamily="34" charset="-122"/>
+                <a:cs typeface="Courier New" pitchFamily="34" charset="-120"/>
+              </a:rPr>
+              <a:t>docker ps</a:t>
+            </a:r>
+            <a:endParaRPr lang="en-US" sz="1300" dirty="0"/>
+          </a:p>
+        </p:txBody>
+      </p:sp>
+      <p:sp>
+        <p:nvSpPr>
+          <p:cNvPr id="16" name="Text 13"/>
+          <p:cNvSpPr txBox="1"/>
+          <p:nvPr/>
+        </p:nvSpPr>
+        <p:spPr>
+          <a:xfrm>
+            <a:off x="2423160" y="4983480"/>
+            <a:ext cx="2194560" cy="731520"/>
+          </a:xfrm>
+          <a:prstGeom prst="rect">
+            <a:avLst/>
+          </a:prstGeom>
+          <a:noFill/>
+          <a:ln/>
+        </p:spPr>
+        <p:txBody>
+          <a:bodyPr wrap="square" lIns="0" tIns="0" rIns="0" bIns="0" rtlCol="0" anchor="ctr"/>
+          <a:lstStyle/>
+          <a:p>
+            <a:pPr indent="0" marL="0">
+              <a:buNone/>
+            </a:pPr>
+            <a:r>
+              <a:rPr lang="en-US" sz="1400" dirty="0">
+                <a:solidFill>
+                  <a:srgbClr val="F5F6FA"/>
+                </a:solidFill>
+                <a:latin typeface="맑은 고딕" pitchFamily="34" charset="0"/>
+                <a:ea typeface="맑은 고딕" pitchFamily="34" charset="-122"/>
+                <a:cs typeface="맑은 고딕" pitchFamily="34" charset="-120"/>
+              </a:rPr>
+              <a:t>실행 중인 컨테이너 보기</a:t>
+            </a:r>
+            <a:endParaRPr lang="en-US" sz="1400" dirty="0"/>
+          </a:p>
+        </p:txBody>
+      </p:sp>
+    </p:spTree>
+  </p:cSld>
+  <p:clrMapOvr>
+    <a:masterClrMapping/>
+  </p:clrMapOvr>
+</p:sld>
+</file>
+
+<file path=ppt/slides/slide12.xml><?xml version="1.0" encoding="utf-8"?>
+<p:sld xmlns:a="http://schemas.openxmlformats.org/drawingml/2006/main" xmlns:r="http://schemas.openxmlformats.org/officeDocument/2006/relationships" xmlns:p="http://schemas.openxmlformats.org/presentationml/2006/main">
+  <p:cSld name="Slide 12">
+    <p:bg>
+      <p:bgPr>
+        <a:solidFill>
+          <a:srgbClr val="1E1F29"/>
+        </a:solidFill>
+      </p:bgPr>
+    </p:bg>
+    <p:spTree>
+      <p:nvGrpSpPr>
+        <p:cNvPr id="1" name=""/>
+        <p:cNvGrpSpPr/>
+        <p:nvPr/>
+      </p:nvGrpSpPr>
+      <p:grpSpPr>
+        <a:xfrm>
+          <a:off x="0" y="0"/>
+          <a:ext cx="0" cy="0"/>
+          <a:chOff x="0" y="0"/>
+          <a:chExt cx="0" cy="0"/>
+        </a:xfrm>
+      </p:grpSpPr>
+      <p:sp>
+        <p:nvSpPr>
+          <p:cNvPr id="2" name="타이틀"/>
+          <p:cNvSpPr txBox="1"/>
+          <p:nvPr/>
+        </p:nvSpPr>
+        <p:spPr>
+          <a:xfrm>
+            <a:off x="209398" y="1158545"/>
+            <a:ext cx="4663440" cy="831190"/>
+          </a:xfrm>
+          <a:prstGeom prst="rect">
+            <a:avLst/>
+          </a:prstGeom>
+          <a:noFill/>
+          <a:ln/>
+        </p:spPr>
+        <p:txBody>
+          <a:bodyPr wrap="square" lIns="0" tIns="0" rIns="0" bIns="0" rtlCol="0" anchor="ctr"/>
+          <a:lstStyle/>
+          <a:p>
+            <a:pPr algn="l" indent="0" marL="0">
+              <a:buNone/>
+            </a:pPr>
+            <a:r>
+              <a:rPr lang="en-US" sz="2400" dirty="0">
+                <a:solidFill>
+                  <a:srgbClr val="F5F6FA"/>
+                </a:solidFill>
+                <a:latin typeface="HY견고딕" pitchFamily="34" charset="0"/>
+                <a:ea typeface="HY견고딕" pitchFamily="34" charset="-122"/>
+                <a:cs typeface="HY견고딕" pitchFamily="34" charset="-120"/>
+              </a:rPr>
+              <a:t>2회차 · 이미지와 컨테이너</a:t>
+            </a:r>
+            <a:endParaRPr lang="en-US" sz="2400" dirty="0"/>
+          </a:p>
+        </p:txBody>
+      </p:sp>
+      <p:sp>
+        <p:nvSpPr>
+          <p:cNvPr id="3" name="자막영역"/>
+          <p:cNvSpPr txBox="1"/>
+          <p:nvPr/>
+        </p:nvSpPr>
+        <p:spPr>
+          <a:xfrm>
+            <a:off x="260604" y="6012180"/>
+            <a:ext cx="4661611" cy="1252728"/>
+          </a:xfrm>
+          <a:prstGeom prst="rect">
+            <a:avLst/>
+          </a:prstGeom>
+          <a:noFill/>
+          <a:ln/>
+        </p:spPr>
+        <p:txBody>
+          <a:bodyPr wrap="square" lIns="635" tIns="635" rIns="635" bIns="635" rtlCol="0" anchor="ctr"/>
+          <a:lstStyle/>
+          <a:p>
+            <a:pPr algn="ctr" indent="0" marL="0">
+              <a:buNone/>
+            </a:pPr>
+            <a:r>
+              <a:rPr lang="en-US" sz="1500" dirty="0">
+                <a:solidFill>
+                  <a:srgbClr val="F5F6FA"/>
+                </a:solidFill>
+                <a:latin typeface="맑은 고딕" pitchFamily="34" charset="0"/>
+                <a:ea typeface="맑은 고딕" pitchFamily="34" charset="-122"/>
+                <a:cs typeface="맑은 고딕" pitchFamily="34" charset="-120"/>
+              </a:rPr>
               <a:t>다음 시간에는 컨테이너를 켜고 끄는 방법을 알아봅니다.</a:t>
             </a:r>
             <a:endParaRPr lang="en-US" sz="1500" dirty="0"/>
@@ -2483,7 +3809,7 @@
                 <a:ea typeface="맑은 고딕" pitchFamily="34" charset="-122"/>
                 <a:cs typeface="맑은 고딕" pitchFamily="34" charset="-120"/>
               </a:rPr>
-              <a:t>docker pull 명령으로 Docker Hub에서 nginx 이미지를 내려받습니다.</a:t>
+              <a:t>이미지는 한 번 만들어 두면 어디서든 똑같이 실행할 수 있습니다.</a:t>
             </a:r>
             <a:endParaRPr lang="en-US" sz="1500" dirty="0"/>
           </a:p>
@@ -2491,172 +3817,24 @@
       </p:sp>
       <p:sp>
         <p:nvSpPr>
-          <p:cNvPr id="5" name="터미널탭"/>
+          <p:cNvPr id="5" name="이미지카드"/>
           <p:cNvSpPr/>
           <p:nvPr/>
         </p:nvSpPr>
         <p:spPr>
           <a:xfrm>
-            <a:off x="395935" y="2404872"/>
-            <a:ext cx="1542593" cy="319126"/>
+            <a:off x="822960" y="2377440"/>
+            <a:ext cx="3474720" cy="914400"/>
           </a:xfrm>
           <a:prstGeom prst="roundRect">
             <a:avLst>
-              <a:gd name="adj" fmla="val 17192"/>
+              <a:gd name="adj" fmla="val 15000"/>
             </a:avLst>
           </a:prstGeom>
           <a:solidFill>
-            <a:srgbClr val="13141C"/>
+            <a:srgbClr val="3B2F55"/>
           </a:solidFill>
-          <a:ln w="9525">
-            <a:solidFill>
-              <a:srgbClr val="393B4A"/>
-            </a:solidFill>
-            <a:prstDash val="solid"/>
-          </a:ln>
-        </p:spPr>
-      </p:sp>
-      <p:sp>
-        <p:nvSpPr>
-          <p:cNvPr id="6" name="Text 3"/>
-          <p:cNvSpPr txBox="1"/>
-          <p:nvPr/>
-        </p:nvSpPr>
-        <p:spPr>
-          <a:xfrm>
-            <a:off x="395935" y="2404872"/>
-            <a:ext cx="1542593" cy="319126"/>
-          </a:xfrm>
-          <a:prstGeom prst="rect">
-            <a:avLst/>
-          </a:prstGeom>
-          <a:noFill/>
-          <a:ln/>
-        </p:spPr>
-        <p:txBody>
-          <a:bodyPr wrap="square" lIns="0" tIns="0" rIns="0" bIns="0" rtlCol="0" anchor="ctr"/>
-          <a:lstStyle/>
-          <a:p>
-            <a:pPr algn="ctr" indent="0" marL="0">
-              <a:buNone/>
-            </a:pPr>
-            <a:r>
-              <a:rPr lang="en-US" sz="1125" b="1" dirty="0">
-                <a:solidFill>
-                  <a:srgbClr val="F5F6FA"/>
-                </a:solidFill>
-                <a:latin typeface="Courier New" pitchFamily="34" charset="0"/>
-                <a:ea typeface="Courier New" pitchFamily="34" charset="-122"/>
-                <a:cs typeface="Courier New" pitchFamily="34" charset="-120"/>
-              </a:rPr>
-              <a:t>terminal</a:t>
-            </a:r>
-            <a:endParaRPr lang="en-US" sz="1125" dirty="0"/>
-          </a:p>
-        </p:txBody>
-      </p:sp>
-      <p:sp>
-        <p:nvSpPr>
-          <p:cNvPr id="7" name="터미널박스"/>
-          <p:cNvSpPr/>
-          <p:nvPr/>
-        </p:nvSpPr>
-        <p:spPr>
-          <a:xfrm>
-            <a:off x="395935" y="2827325"/>
-            <a:ext cx="4526280" cy="2124151"/>
-          </a:xfrm>
-          <a:prstGeom prst="roundRect">
-            <a:avLst>
-              <a:gd name="adj" fmla="val 3444"/>
-            </a:avLst>
-          </a:prstGeom>
-          <a:solidFill>
-            <a:srgbClr val="13141C"/>
-          </a:solidFill>
-          <a:ln w="9525">
-            <a:solidFill>
-              <a:srgbClr val="393B4A"/>
-            </a:solidFill>
-            <a:prstDash val="solid"/>
-          </a:ln>
-        </p:spPr>
-      </p:sp>
-      <p:sp>
-        <p:nvSpPr>
-          <p:cNvPr id="8" name="터미널줄1"/>
-          <p:cNvSpPr txBox="1"/>
-          <p:nvPr/>
-        </p:nvSpPr>
-        <p:spPr>
-          <a:xfrm>
-            <a:off x="523951" y="2955341"/>
-            <a:ext cx="4270248" cy="279400"/>
-          </a:xfrm>
-          <a:prstGeom prst="rect">
-            <a:avLst/>
-          </a:prstGeom>
-          <a:noFill/>
-          <a:ln/>
-        </p:spPr>
-        <p:txBody>
-          <a:bodyPr wrap="none" lIns="0" tIns="0" rIns="0" bIns="0" rtlCol="0" anchor="ctr"/>
-          <a:lstStyle/>
-          <a:p>
-            <a:pPr indent="0" marL="0">
-              <a:buNone/>
-            </a:pPr>
-            <a:r>
-              <a:rPr lang="en-US" sz="1400" b="1" dirty="0">
-                <a:solidFill>
-                  <a:srgbClr val="50FA7B"/>
-                </a:solidFill>
-                <a:latin typeface="Courier New" pitchFamily="34" charset="0"/>
-                <a:ea typeface="Courier New" pitchFamily="34" charset="-122"/>
-                <a:cs typeface="Courier New" pitchFamily="34" charset="-120"/>
-              </a:rPr>
-              <a:t>user@PC:~$ </a:t>
-            </a:r>
-            <a:pPr indent="0" marL="0">
-              <a:buNone/>
-            </a:pPr>
-            <a:r>
-              <a:rPr lang="en-US" sz="1400" dirty="0">
-                <a:solidFill>
-                  <a:srgbClr val="F5F6FA"/>
-                </a:solidFill>
-                <a:latin typeface="Courier New" pitchFamily="34" charset="0"/>
-                <a:ea typeface="Courier New" pitchFamily="34" charset="-122"/>
-                <a:cs typeface="Courier New" pitchFamily="34" charset="-120"/>
-              </a:rPr>
-              <a:t>docker pull nginx:alpine</a:t>
-            </a:r>
-            <a:endParaRPr lang="en-US" sz="1400" dirty="0"/>
-          </a:p>
-        </p:txBody>
-      </p:sp>
-      <p:sp>
-        <p:nvSpPr>
-          <p:cNvPr id="9" name="강조"/>
-          <p:cNvSpPr/>
-          <p:nvPr/>
-        </p:nvSpPr>
-        <p:spPr>
-          <a:xfrm>
-            <a:off x="459943" y="2946197"/>
-            <a:ext cx="4398264" cy="297688"/>
-          </a:xfrm>
-          <a:prstGeom prst="roundRect">
-            <a:avLst>
-              <a:gd name="adj" fmla="val 15358"/>
-            </a:avLst>
-          </a:prstGeom>
-          <a:solidFill>
-            <a:srgbClr val="13141C">
-              <a:alpha val="0"/>
-            </a:srgbClr>
-          </a:solidFill>
-          <a:ln w="22225">
+          <a:ln w="19050">
             <a:solidFill>
               <a:srgbClr val="FF79C6"/>
             </a:solidFill>
@@ -2666,26 +3844,104 @@
       </p:sp>
       <p:sp>
         <p:nvSpPr>
-          <p:cNvPr id="10" name="설명라벨"/>
+          <p:cNvPr id="6" name="Text 3"/>
+          <p:cNvSpPr txBox="1"/>
+          <p:nvPr/>
+        </p:nvSpPr>
+        <p:spPr>
+          <a:xfrm>
+            <a:off x="822960" y="2377440"/>
+            <a:ext cx="3474720" cy="914400"/>
+          </a:xfrm>
+          <a:prstGeom prst="rect">
+            <a:avLst/>
+          </a:prstGeom>
+          <a:noFill/>
+          <a:ln/>
+        </p:spPr>
+        <p:txBody>
+          <a:bodyPr wrap="square" lIns="0" tIns="0" rIns="0" bIns="0" rtlCol="0" anchor="ctr"/>
+          <a:lstStyle/>
+          <a:p>
+            <a:pPr algn="ctr" indent="0" marL="0">
+              <a:buNone/>
+            </a:pPr>
+            <a:r>
+              <a:rPr lang="en-US" sz="2000" b="1" dirty="0">
+                <a:solidFill>
+                  <a:srgbClr val="F5F6FA"/>
+                </a:solidFill>
+                <a:latin typeface="맑은 고딕" pitchFamily="34" charset="0"/>
+                <a:ea typeface="맑은 고딕" pitchFamily="34" charset="-122"/>
+                <a:cs typeface="맑은 고딕" pitchFamily="34" charset="-120"/>
+              </a:rPr>
+              <a:t>이미지 (Image)</a:t>
+            </a:r>
+            <a:endParaRPr lang="en-US" sz="2000" dirty="0"/>
+          </a:p>
+        </p:txBody>
+      </p:sp>
+      <p:sp>
+        <p:nvSpPr>
+          <p:cNvPr id="7" name="Text 4"/>
+          <p:cNvSpPr txBox="1"/>
+          <p:nvPr/>
+        </p:nvSpPr>
+        <p:spPr>
+          <a:xfrm>
+            <a:off x="457200" y="3429000"/>
+            <a:ext cx="1280160" cy="411480"/>
+          </a:xfrm>
+          <a:prstGeom prst="rect">
+            <a:avLst/>
+          </a:prstGeom>
+          <a:noFill/>
+          <a:ln/>
+        </p:spPr>
+        <p:txBody>
+          <a:bodyPr wrap="square" lIns="0" tIns="0" rIns="0" bIns="0" rtlCol="0" anchor="ctr"/>
+          <a:lstStyle/>
+          <a:p>
+            <a:pPr algn="ctr" indent="0" marL="0">
+              <a:buNone/>
+            </a:pPr>
+            <a:r>
+              <a:rPr lang="en-US" sz="1400" b="1" dirty="0">
+                <a:solidFill>
+                  <a:srgbClr val="FF79C6"/>
+                </a:solidFill>
+                <a:latin typeface="Courier New" pitchFamily="34" charset="0"/>
+                <a:ea typeface="Courier New" pitchFamily="34" charset="-122"/>
+                <a:cs typeface="Courier New" pitchFamily="34" charset="-120"/>
+              </a:rPr>
+              <a:t>▼</a:t>
+            </a:r>
+            <a:endParaRPr lang="en-US" sz="1400" dirty="0"/>
+          </a:p>
+        </p:txBody>
+      </p:sp>
+      <p:sp>
+        <p:nvSpPr>
+          <p:cNvPr id="8" name="컨테이너카드1"/>
           <p:cNvSpPr/>
           <p:nvPr/>
         </p:nvSpPr>
         <p:spPr>
           <a:xfrm>
-            <a:off x="395935" y="5157216"/>
-            <a:ext cx="4526280" cy="384048"/>
+            <a:off x="457200" y="3977640"/>
+            <a:ext cx="1280160" cy="1280160"/>
           </a:xfrm>
           <a:prstGeom prst="roundRect">
             <a:avLst>
-              <a:gd name="adj" fmla="val 14286"/>
+              <a:gd name="adj" fmla="val 8571"/>
             </a:avLst>
           </a:prstGeom>
           <a:solidFill>
-            <a:srgbClr val="3B2F55"/>
+            <a:srgbClr val="24473A"/>
           </a:solidFill>
-          <a:ln w="6350">
+          <a:ln w="19050">
             <a:solidFill>
-              <a:srgbClr val="3B2F55"/>
+              <a:srgbClr val="50FA7B"/>
             </a:solidFill>
             <a:prstDash val="solid"/>
           </a:ln>
@@ -2693,30 +3949,30 @@
       </p:sp>
       <p:sp>
         <p:nvSpPr>
-          <p:cNvPr id="11" name="Text 8"/>
-          <p:cNvSpPr txBox="1"/>
-          <p:nvPr/>
-        </p:nvSpPr>
-        <p:spPr>
-          <a:xfrm>
-            <a:off x="395935" y="5157216"/>
-            <a:ext cx="4526280" cy="384048"/>
-          </a:xfrm>
-          <a:prstGeom prst="rect">
-            <a:avLst/>
-          </a:prstGeom>
-          <a:noFill/>
-          <a:ln/>
-        </p:spPr>
-        <p:txBody>
-          <a:bodyPr wrap="square" lIns="0" tIns="0" rIns="0" bIns="0" rtlCol="0" anchor="ctr"/>
+          <p:cNvPr id="9" name="Text 6"/>
+          <p:cNvSpPr txBox="1"/>
+          <p:nvPr/>
+        </p:nvSpPr>
+        <p:spPr>
+          <a:xfrm>
+            <a:off x="457200" y="3977640"/>
+            <a:ext cx="1280160" cy="1280160"/>
+          </a:xfrm>
+          <a:prstGeom prst="rect">
+            <a:avLst/>
+          </a:prstGeom>
+          <a:noFill/>
+          <a:ln/>
+        </p:spPr>
+        <p:txBody>
+          <a:bodyPr wrap="square" lIns="381" tIns="381" rIns="381" bIns="381" rtlCol="0" anchor="ctr"/>
           <a:lstStyle/>
           <a:p>
             <a:pPr algn="ctr" indent="0" marL="0">
               <a:buNone/>
             </a:pPr>
             <a:r>
-              <a:rPr lang="en-US" sz="1200" b="1" dirty="0">
+              <a:rPr lang="en-US" sz="1300" b="1" dirty="0">
                 <a:solidFill>
                   <a:srgbClr val="F5F6FA"/>
                 </a:solidFill>
@@ -2724,9 +3980,270 @@
                 <a:ea typeface="맑은 고딕" pitchFamily="34" charset="-122"/>
                 <a:cs typeface="맑은 고딕" pitchFamily="34" charset="-120"/>
               </a:rPr>
-              <a:t>이미지 내려받기: docker pull</a:t>
-            </a:r>
-            <a:endParaRPr lang="en-US" sz="1200" dirty="0"/>
+              <a:t>컨테이너</a:t>
+            </a:r>
+            <a:endParaRPr lang="en-US" sz="1300" dirty="0"/>
+          </a:p>
+          <a:p>
+            <a:pPr algn="ctr" indent="0" marL="0">
+              <a:buNone/>
+            </a:pPr>
+            <a:r>
+              <a:rPr lang="en-US" sz="1400" dirty="0">
+                <a:solidFill>
+                  <a:srgbClr val="F5F6FA"/>
+                </a:solidFill>
+                <a:latin typeface="맑은 고딕" pitchFamily="34" charset="0"/>
+                <a:ea typeface="맑은 고딕" pitchFamily="34" charset="-122"/>
+                <a:cs typeface="맑은 고딕" pitchFamily="34" charset="-120"/>
+              </a:rPr>
+              <a:t>내 PC</a:t>
+            </a:r>
+            <a:endParaRPr lang="en-US" sz="1300" dirty="0"/>
+          </a:p>
+        </p:txBody>
+      </p:sp>
+      <p:sp>
+        <p:nvSpPr>
+          <p:cNvPr id="10" name="Text 7"/>
+          <p:cNvSpPr txBox="1"/>
+          <p:nvPr/>
+        </p:nvSpPr>
+        <p:spPr>
+          <a:xfrm>
+            <a:off x="1920240" y="3429000"/>
+            <a:ext cx="1280160" cy="411480"/>
+          </a:xfrm>
+          <a:prstGeom prst="rect">
+            <a:avLst/>
+          </a:prstGeom>
+          <a:noFill/>
+          <a:ln/>
+        </p:spPr>
+        <p:txBody>
+          <a:bodyPr wrap="square" lIns="0" tIns="0" rIns="0" bIns="0" rtlCol="0" anchor="ctr"/>
+          <a:lstStyle/>
+          <a:p>
+            <a:pPr algn="ctr" indent="0" marL="0">
+              <a:buNone/>
+            </a:pPr>
+            <a:r>
+              <a:rPr lang="en-US" sz="1400" b="1" dirty="0">
+                <a:solidFill>
+                  <a:srgbClr val="FF79C6"/>
+                </a:solidFill>
+                <a:latin typeface="Courier New" pitchFamily="34" charset="0"/>
+                <a:ea typeface="Courier New" pitchFamily="34" charset="-122"/>
+                <a:cs typeface="Courier New" pitchFamily="34" charset="-120"/>
+              </a:rPr>
+              <a:t>▼</a:t>
+            </a:r>
+            <a:endParaRPr lang="en-US" sz="1400" dirty="0"/>
+          </a:p>
+        </p:txBody>
+      </p:sp>
+      <p:sp>
+        <p:nvSpPr>
+          <p:cNvPr id="11" name="컨테이너카드2"/>
+          <p:cNvSpPr/>
+          <p:nvPr/>
+        </p:nvSpPr>
+        <p:spPr>
+          <a:xfrm>
+            <a:off x="1920240" y="3977640"/>
+            <a:ext cx="1280160" cy="1280160"/>
+          </a:xfrm>
+          <a:prstGeom prst="roundRect">
+            <a:avLst>
+              <a:gd name="adj" fmla="val 8571"/>
+            </a:avLst>
+          </a:prstGeom>
+          <a:solidFill>
+            <a:srgbClr val="24473A"/>
+          </a:solidFill>
+          <a:ln w="19050">
+            <a:solidFill>
+              <a:srgbClr val="50FA7B"/>
+            </a:solidFill>
+            <a:prstDash val="solid"/>
+          </a:ln>
+        </p:spPr>
+      </p:sp>
+      <p:sp>
+        <p:nvSpPr>
+          <p:cNvPr id="12" name="Text 9"/>
+          <p:cNvSpPr txBox="1"/>
+          <p:nvPr/>
+        </p:nvSpPr>
+        <p:spPr>
+          <a:xfrm>
+            <a:off x="1920240" y="3977640"/>
+            <a:ext cx="1280160" cy="1280160"/>
+          </a:xfrm>
+          <a:prstGeom prst="rect">
+            <a:avLst/>
+          </a:prstGeom>
+          <a:noFill/>
+          <a:ln/>
+        </p:spPr>
+        <p:txBody>
+          <a:bodyPr wrap="square" lIns="381" tIns="381" rIns="381" bIns="381" rtlCol="0" anchor="ctr"/>
+          <a:lstStyle/>
+          <a:p>
+            <a:pPr algn="ctr" indent="0" marL="0">
+              <a:buNone/>
+            </a:pPr>
+            <a:r>
+              <a:rPr lang="en-US" sz="1300" b="1" dirty="0">
+                <a:solidFill>
+                  <a:srgbClr val="F5F6FA"/>
+                </a:solidFill>
+                <a:latin typeface="맑은 고딕" pitchFamily="34" charset="0"/>
+                <a:ea typeface="맑은 고딕" pitchFamily="34" charset="-122"/>
+                <a:cs typeface="맑은 고딕" pitchFamily="34" charset="-120"/>
+              </a:rPr>
+              <a:t>컨테이너</a:t>
+            </a:r>
+            <a:endParaRPr lang="en-US" sz="1300" dirty="0"/>
+          </a:p>
+          <a:p>
+            <a:pPr algn="ctr" indent="0" marL="0">
+              <a:buNone/>
+            </a:pPr>
+            <a:r>
+              <a:rPr lang="en-US" sz="1400" dirty="0">
+                <a:solidFill>
+                  <a:srgbClr val="F5F6FA"/>
+                </a:solidFill>
+                <a:latin typeface="맑은 고딕" pitchFamily="34" charset="0"/>
+                <a:ea typeface="맑은 고딕" pitchFamily="34" charset="-122"/>
+                <a:cs typeface="맑은 고딕" pitchFamily="34" charset="-120"/>
+              </a:rPr>
+              <a:t>서버</a:t>
+            </a:r>
+            <a:endParaRPr lang="en-US" sz="1300" dirty="0"/>
+          </a:p>
+        </p:txBody>
+      </p:sp>
+      <p:sp>
+        <p:nvSpPr>
+          <p:cNvPr id="13" name="Text 10"/>
+          <p:cNvSpPr txBox="1"/>
+          <p:nvPr/>
+        </p:nvSpPr>
+        <p:spPr>
+          <a:xfrm>
+            <a:off x="3383280" y="3429000"/>
+            <a:ext cx="1280160" cy="411480"/>
+          </a:xfrm>
+          <a:prstGeom prst="rect">
+            <a:avLst/>
+          </a:prstGeom>
+          <a:noFill/>
+          <a:ln/>
+        </p:spPr>
+        <p:txBody>
+          <a:bodyPr wrap="square" lIns="0" tIns="0" rIns="0" bIns="0" rtlCol="0" anchor="ctr"/>
+          <a:lstStyle/>
+          <a:p>
+            <a:pPr algn="ctr" indent="0" marL="0">
+              <a:buNone/>
+            </a:pPr>
+            <a:r>
+              <a:rPr lang="en-US" sz="1400" b="1" dirty="0">
+                <a:solidFill>
+                  <a:srgbClr val="FF79C6"/>
+                </a:solidFill>
+                <a:latin typeface="Courier New" pitchFamily="34" charset="0"/>
+                <a:ea typeface="Courier New" pitchFamily="34" charset="-122"/>
+                <a:cs typeface="Courier New" pitchFamily="34" charset="-120"/>
+              </a:rPr>
+              <a:t>▼</a:t>
+            </a:r>
+            <a:endParaRPr lang="en-US" sz="1400" dirty="0"/>
+          </a:p>
+        </p:txBody>
+      </p:sp>
+      <p:sp>
+        <p:nvSpPr>
+          <p:cNvPr id="14" name="컨테이너카드3"/>
+          <p:cNvSpPr/>
+          <p:nvPr/>
+        </p:nvSpPr>
+        <p:spPr>
+          <a:xfrm>
+            <a:off x="3383280" y="3977640"/>
+            <a:ext cx="1280160" cy="1280160"/>
+          </a:xfrm>
+          <a:prstGeom prst="roundRect">
+            <a:avLst>
+              <a:gd name="adj" fmla="val 8571"/>
+            </a:avLst>
+          </a:prstGeom>
+          <a:solidFill>
+            <a:srgbClr val="24473A"/>
+          </a:solidFill>
+          <a:ln w="19050">
+            <a:solidFill>
+              <a:srgbClr val="50FA7B"/>
+            </a:solidFill>
+            <a:prstDash val="solid"/>
+          </a:ln>
+        </p:spPr>
+      </p:sp>
+      <p:sp>
+        <p:nvSpPr>
+          <p:cNvPr id="15" name="Text 12"/>
+          <p:cNvSpPr txBox="1"/>
+          <p:nvPr/>
+        </p:nvSpPr>
+        <p:spPr>
+          <a:xfrm>
+            <a:off x="3383280" y="3977640"/>
+            <a:ext cx="1280160" cy="1280160"/>
+          </a:xfrm>
+          <a:prstGeom prst="rect">
+            <a:avLst/>
+          </a:prstGeom>
+          <a:noFill/>
+          <a:ln/>
+        </p:spPr>
+        <p:txBody>
+          <a:bodyPr wrap="square" lIns="381" tIns="381" rIns="381" bIns="381" rtlCol="0" anchor="ctr"/>
+          <a:lstStyle/>
+          <a:p>
+            <a:pPr algn="ctr" indent="0" marL="0">
+              <a:buNone/>
+            </a:pPr>
+            <a:r>
+              <a:rPr lang="en-US" sz="1300" b="1" dirty="0">
+                <a:solidFill>
+                  <a:srgbClr val="F5F6FA"/>
+                </a:solidFill>
+                <a:latin typeface="맑은 고딕" pitchFamily="34" charset="0"/>
+                <a:ea typeface="맑은 고딕" pitchFamily="34" charset="-122"/>
+                <a:cs typeface="맑은 고딕" pitchFamily="34" charset="-120"/>
+              </a:rPr>
+              <a:t>컨테이너</a:t>
+            </a:r>
+            <a:endParaRPr lang="en-US" sz="1300" dirty="0"/>
+          </a:p>
+          <a:p>
+            <a:pPr algn="ctr" indent="0" marL="0">
+              <a:buNone/>
+            </a:pPr>
+            <a:r>
+              <a:rPr lang="en-US" sz="1400" dirty="0">
+                <a:solidFill>
+                  <a:srgbClr val="F5F6FA"/>
+                </a:solidFill>
+                <a:latin typeface="맑은 고딕" pitchFamily="34" charset="0"/>
+                <a:ea typeface="맑은 고딕" pitchFamily="34" charset="-122"/>
+                <a:cs typeface="맑은 고딕" pitchFamily="34" charset="-120"/>
+              </a:rPr>
+              <a:t>친구 PC</a:t>
+            </a:r>
+            <a:endParaRPr lang="en-US" sz="1300" dirty="0"/>
           </a:p>
         </p:txBody>
       </p:sp>
@@ -2834,7 +4351,7 @@
                 <a:ea typeface="맑은 고딕" pitchFamily="34" charset="-122"/>
                 <a:cs typeface="맑은 고딕" pitchFamily="34" charset="-120"/>
               </a:rPr>
-              <a:t>마지막에 Downloaded 메시지가 나오면 내려받기가 끝난 것입니다.</a:t>
+              <a:t>docker pull 명령으로 Docker Hub에서 nginx 이미지를 내려받습니다.</a:t>
             </a:r>
             <a:endParaRPr lang="en-US" sz="1500" dirty="0"/>
           </a:p>
@@ -2942,7 +4459,7 @@
         <p:spPr>
           <a:xfrm>
             <a:off x="523951" y="2955341"/>
-            <a:ext cx="4270248" cy="228600"/>
+            <a:ext cx="4270248" cy="279400"/>
           </a:xfrm>
           <a:prstGeom prst="rect">
             <a:avLst/>
@@ -2958,7 +4475,7 @@
               <a:buNone/>
             </a:pPr>
             <a:r>
-              <a:rPr lang="en-US" sz="1100" b="1" dirty="0">
+              <a:rPr lang="en-US" sz="1400" b="1" dirty="0">
                 <a:solidFill>
                   <a:srgbClr val="50FA7B"/>
                 </a:solidFill>
@@ -2972,7 +4489,7 @@
               <a:buNone/>
             </a:pPr>
             <a:r>
-              <a:rPr lang="en-US" sz="1100" dirty="0">
+              <a:rPr lang="en-US" sz="1400" dirty="0">
                 <a:solidFill>
                   <a:srgbClr val="F5F6FA"/>
                 </a:solidFill>
@@ -2982,180 +4499,24 @@
               </a:rPr>
               <a:t>docker pull nginx:alpine</a:t>
             </a:r>
-            <a:endParaRPr lang="en-US" sz="1100" dirty="0"/>
-          </a:p>
-        </p:txBody>
-      </p:sp>
-      <p:sp>
-        <p:nvSpPr>
-          <p:cNvPr id="9" name="터미널줄2"/>
-          <p:cNvSpPr txBox="1"/>
-          <p:nvPr/>
-        </p:nvSpPr>
-        <p:spPr>
-          <a:xfrm>
-            <a:off x="523951" y="3183941"/>
-            <a:ext cx="4270248" cy="228600"/>
-          </a:xfrm>
-          <a:prstGeom prst="rect">
-            <a:avLst/>
-          </a:prstGeom>
-          <a:noFill/>
-          <a:ln/>
-        </p:spPr>
-        <p:txBody>
-          <a:bodyPr wrap="none" lIns="0" tIns="0" rIns="0" bIns="0" rtlCol="0" anchor="ctr"/>
-          <a:lstStyle/>
-          <a:p>
-            <a:pPr indent="0" marL="0">
-              <a:buNone/>
-            </a:pPr>
-            <a:r>
-              <a:rPr lang="en-US" sz="1100" dirty="0">
-                <a:solidFill>
-                  <a:srgbClr val="F5F6FA"/>
-                </a:solidFill>
-                <a:latin typeface="Courier New" pitchFamily="34" charset="0"/>
-                <a:ea typeface="Courier New" pitchFamily="34" charset="-122"/>
-                <a:cs typeface="Courier New" pitchFamily="34" charset="-120"/>
-              </a:rPr>
-              <a:t>alpine: Pulling from library/nginx</a:t>
-            </a:r>
-            <a:endParaRPr lang="en-US" sz="1100" dirty="0"/>
-          </a:p>
-        </p:txBody>
-      </p:sp>
-      <p:sp>
-        <p:nvSpPr>
-          <p:cNvPr id="10" name="터미널줄3"/>
-          <p:cNvSpPr txBox="1"/>
-          <p:nvPr/>
-        </p:nvSpPr>
-        <p:spPr>
-          <a:xfrm>
-            <a:off x="523951" y="3412541"/>
-            <a:ext cx="4270248" cy="228600"/>
-          </a:xfrm>
-          <a:prstGeom prst="rect">
-            <a:avLst/>
-          </a:prstGeom>
-          <a:noFill/>
-          <a:ln/>
-        </p:spPr>
-        <p:txBody>
-          <a:bodyPr wrap="none" lIns="0" tIns="0" rIns="0" bIns="0" rtlCol="0" anchor="ctr"/>
-          <a:lstStyle/>
-          <a:p>
-            <a:pPr indent="0" marL="0">
-              <a:buNone/>
-            </a:pPr>
-            <a:r>
-              <a:rPr lang="en-US" sz="1100" dirty="0">
-                <a:solidFill>
-                  <a:srgbClr val="6B7280"/>
-                </a:solidFill>
-                <a:latin typeface="Courier New" pitchFamily="34" charset="0"/>
-                <a:ea typeface="Courier New" pitchFamily="34" charset="-122"/>
-                <a:cs typeface="Courier New" pitchFamily="34" charset="-120"/>
-              </a:rPr>
-              <a:t>...</a:t>
-            </a:r>
-            <a:endParaRPr lang="en-US" sz="1100" dirty="0"/>
-          </a:p>
-        </p:txBody>
-      </p:sp>
-      <p:sp>
-        <p:nvSpPr>
-          <p:cNvPr id="11" name="터미널줄4"/>
-          <p:cNvSpPr txBox="1"/>
-          <p:nvPr/>
-        </p:nvSpPr>
-        <p:spPr>
-          <a:xfrm>
-            <a:off x="523951" y="3641141"/>
-            <a:ext cx="4270248" cy="228600"/>
-          </a:xfrm>
-          <a:prstGeom prst="rect">
-            <a:avLst/>
-          </a:prstGeom>
-          <a:noFill/>
-          <a:ln/>
-        </p:spPr>
-        <p:txBody>
-          <a:bodyPr wrap="none" lIns="0" tIns="0" rIns="0" bIns="0" rtlCol="0" anchor="ctr"/>
-          <a:lstStyle/>
-          <a:p>
-            <a:pPr indent="0" marL="0">
-              <a:buNone/>
-            </a:pPr>
-            <a:r>
-              <a:rPr lang="en-US" sz="1100" dirty="0">
-                <a:solidFill>
-                  <a:srgbClr val="F5F6FA"/>
-                </a:solidFill>
-                <a:latin typeface="Courier New" pitchFamily="34" charset="0"/>
-                <a:ea typeface="Courier New" pitchFamily="34" charset="-122"/>
-                <a:cs typeface="Courier New" pitchFamily="34" charset="-120"/>
-              </a:rPr>
-              <a:t>Digest: sha256:df221db836e1754089190208c…</a:t>
-            </a:r>
-            <a:endParaRPr lang="en-US" sz="1100" dirty="0"/>
-          </a:p>
-        </p:txBody>
-      </p:sp>
-      <p:sp>
-        <p:nvSpPr>
-          <p:cNvPr id="12" name="터미널줄5"/>
-          <p:cNvSpPr txBox="1"/>
-          <p:nvPr/>
-        </p:nvSpPr>
-        <p:spPr>
-          <a:xfrm>
-            <a:off x="523951" y="3869741"/>
-            <a:ext cx="4270248" cy="228600"/>
-          </a:xfrm>
-          <a:prstGeom prst="rect">
-            <a:avLst/>
-          </a:prstGeom>
-          <a:noFill/>
-          <a:ln/>
-        </p:spPr>
-        <p:txBody>
-          <a:bodyPr wrap="none" lIns="0" tIns="0" rIns="0" bIns="0" rtlCol="0" anchor="ctr"/>
-          <a:lstStyle/>
-          <a:p>
-            <a:pPr indent="0" marL="0">
-              <a:buNone/>
-            </a:pPr>
-            <a:r>
-              <a:rPr lang="en-US" sz="1100" dirty="0">
-                <a:solidFill>
-                  <a:srgbClr val="F5F6FA"/>
-                </a:solidFill>
-                <a:latin typeface="Courier New" pitchFamily="34" charset="0"/>
-                <a:ea typeface="Courier New" pitchFamily="34" charset="-122"/>
-                <a:cs typeface="Courier New" pitchFamily="34" charset="-120"/>
-              </a:rPr>
-              <a:t>Status: Downloaded newer image for nginx:alpine</a:t>
-            </a:r>
-            <a:endParaRPr lang="en-US" sz="1100" dirty="0"/>
-          </a:p>
-        </p:txBody>
-      </p:sp>
-      <p:sp>
-        <p:nvSpPr>
-          <p:cNvPr id="13" name="강조"/>
+            <a:endParaRPr lang="en-US" sz="1400" dirty="0"/>
+          </a:p>
+        </p:txBody>
+      </p:sp>
+      <p:sp>
+        <p:nvSpPr>
+          <p:cNvPr id="9" name="강조"/>
           <p:cNvSpPr/>
           <p:nvPr/>
         </p:nvSpPr>
         <p:spPr>
           <a:xfrm>
-            <a:off x="459943" y="3860597"/>
-            <a:ext cx="4398264" cy="246888"/>
+            <a:off x="459943" y="2946197"/>
+            <a:ext cx="4398264" cy="297688"/>
           </a:xfrm>
           <a:prstGeom prst="roundRect">
             <a:avLst>
-              <a:gd name="adj" fmla="val 18519"/>
+              <a:gd name="adj" fmla="val 15358"/>
             </a:avLst>
           </a:prstGeom>
           <a:solidFill>
@@ -3165,7 +4526,7 @@
           </a:solidFill>
           <a:ln w="22225">
             <a:solidFill>
-              <a:srgbClr val="50FA7B"/>
+              <a:srgbClr val="FF79C6"/>
             </a:solidFill>
             <a:prstDash val="solid"/>
           </a:ln>
@@ -3173,7 +4534,7 @@
       </p:sp>
       <p:sp>
         <p:nvSpPr>
-          <p:cNvPr id="14" name="설명라벨"/>
+          <p:cNvPr id="10" name="설명라벨"/>
           <p:cNvSpPr/>
           <p:nvPr/>
         </p:nvSpPr>
@@ -3188,11 +4549,11 @@
             </a:avLst>
           </a:prstGeom>
           <a:solidFill>
-            <a:srgbClr val="24473A"/>
+            <a:srgbClr val="3B2F55"/>
           </a:solidFill>
           <a:ln w="6350">
             <a:solidFill>
-              <a:srgbClr val="24473A"/>
+              <a:srgbClr val="3B2F55"/>
             </a:solidFill>
             <a:prstDash val="solid"/>
           </a:ln>
@@ -3200,7 +4561,7 @@
       </p:sp>
       <p:sp>
         <p:nvSpPr>
-          <p:cNvPr id="15" name="Text 12"/>
+          <p:cNvPr id="11" name="Text 8"/>
           <p:cNvSpPr txBox="1"/>
           <p:nvPr/>
         </p:nvSpPr>
@@ -3231,7 +4592,7 @@
                 <a:ea typeface="맑은 고딕" pitchFamily="34" charset="-122"/>
                 <a:cs typeface="맑은 고딕" pitchFamily="34" charset="-120"/>
               </a:rPr>
-              <a:t>pull 실행 결과</a:t>
+              <a:t>이미지 내려받기: docker pull</a:t>
             </a:r>
             <a:endParaRPr lang="en-US" sz="1200" dirty="0"/>
           </a:p>
@@ -3341,7 +4702,7 @@
                 <a:ea typeface="맑은 고딕" pitchFamily="34" charset="-122"/>
                 <a:cs typeface="맑은 고딕" pitchFamily="34" charset="-120"/>
               </a:rPr>
-              <a:t>docker images로 내려받은 이미지를 확인합니다.</a:t>
+              <a:t>마지막에 Downloaded 메시지가 나오면 내려받기가 끝난 것입니다.</a:t>
             </a:r>
             <a:endParaRPr lang="en-US" sz="1500" dirty="0"/>
           </a:p>
@@ -3449,7 +4810,7 @@
         <p:spPr>
           <a:xfrm>
             <a:off x="523951" y="2955341"/>
-            <a:ext cx="4270248" cy="266700"/>
+            <a:ext cx="4270248" cy="228600"/>
           </a:xfrm>
           <a:prstGeom prst="rect">
             <a:avLst/>
@@ -3465,7 +4826,7 @@
               <a:buNone/>
             </a:pPr>
             <a:r>
-              <a:rPr lang="en-US" sz="1300" b="1" dirty="0">
+              <a:rPr lang="en-US" sz="1100" b="1" dirty="0">
                 <a:solidFill>
                   <a:srgbClr val="50FA7B"/>
                 </a:solidFill>
@@ -3479,7 +4840,7 @@
               <a:buNone/>
             </a:pPr>
             <a:r>
-              <a:rPr lang="en-US" sz="1300" dirty="0">
+              <a:rPr lang="en-US" sz="1100" dirty="0">
                 <a:solidFill>
                   <a:srgbClr val="F5F6FA"/>
                 </a:solidFill>
@@ -3487,9 +4848,9 @@
                 <a:ea typeface="Courier New" pitchFamily="34" charset="-122"/>
                 <a:cs typeface="Courier New" pitchFamily="34" charset="-120"/>
               </a:rPr>
-              <a:t>docker images</a:t>
-            </a:r>
-            <a:endParaRPr lang="en-US" sz="1300" dirty="0"/>
+              <a:t>docker pull nginx:alpine</a:t>
+            </a:r>
+            <a:endParaRPr lang="en-US" sz="1100" dirty="0"/>
           </a:p>
         </p:txBody>
       </p:sp>
@@ -3501,8 +4862,8 @@
         </p:nvSpPr>
         <p:spPr>
           <a:xfrm>
-            <a:off x="523951" y="3222041"/>
-            <a:ext cx="4270248" cy="266700"/>
+            <a:off x="523951" y="3183941"/>
+            <a:ext cx="4270248" cy="228600"/>
           </a:xfrm>
           <a:prstGeom prst="rect">
             <a:avLst/>
@@ -3518,17 +4879,17 @@
               <a:buNone/>
             </a:pPr>
             <a:r>
-              <a:rPr lang="en-US" sz="1300" dirty="0">
-                <a:solidFill>
-                  <a:srgbClr val="6B7280"/>
+              <a:rPr lang="en-US" sz="1100" dirty="0">
+                <a:solidFill>
+                  <a:srgbClr val="F5F6FA"/>
                 </a:solidFill>
                 <a:latin typeface="Courier New" pitchFamily="34" charset="0"/>
                 <a:ea typeface="Courier New" pitchFamily="34" charset="-122"/>
                 <a:cs typeface="Courier New" pitchFamily="34" charset="-120"/>
               </a:rPr>
-              <a:t>IMAGE          ID             DISK USAGE</a:t>
-            </a:r>
-            <a:endParaRPr lang="en-US" sz="1300" dirty="0"/>
+              <a:t>alpine: Pulling from library/nginx</a:t>
+            </a:r>
+            <a:endParaRPr lang="en-US" sz="1100" dirty="0"/>
           </a:p>
         </p:txBody>
       </p:sp>
@@ -3540,8 +4901,8 @@
         </p:nvSpPr>
         <p:spPr>
           <a:xfrm>
-            <a:off x="523951" y="3488741"/>
-            <a:ext cx="4270248" cy="266700"/>
+            <a:off x="523951" y="3412541"/>
+            <a:ext cx="4270248" cy="228600"/>
           </a:xfrm>
           <a:prstGeom prst="rect">
             <a:avLst/>
@@ -3557,34 +4918,112 @@
               <a:buNone/>
             </a:pPr>
             <a:r>
-              <a:rPr lang="en-US" sz="1300" dirty="0">
-                <a:solidFill>
-                  <a:srgbClr val="F5F6FA"/>
+              <a:rPr lang="en-US" sz="1100" dirty="0">
+                <a:solidFill>
+                  <a:srgbClr val="6B7280"/>
                 </a:solidFill>
                 <a:latin typeface="Courier New" pitchFamily="34" charset="0"/>
                 <a:ea typeface="Courier New" pitchFamily="34" charset="-122"/>
                 <a:cs typeface="Courier New" pitchFamily="34" charset="-120"/>
               </a:rPr>
-              <a:t>nginx:alpine   df221db836e1   94.4MB</a:t>
-            </a:r>
-            <a:endParaRPr lang="en-US" sz="1300" dirty="0"/>
-          </a:p>
-        </p:txBody>
-      </p:sp>
-      <p:sp>
-        <p:nvSpPr>
-          <p:cNvPr id="11" name="강조"/>
+              <a:t>...</a:t>
+            </a:r>
+            <a:endParaRPr lang="en-US" sz="1100" dirty="0"/>
+          </a:p>
+        </p:txBody>
+      </p:sp>
+      <p:sp>
+        <p:nvSpPr>
+          <p:cNvPr id="11" name="터미널줄4"/>
+          <p:cNvSpPr txBox="1"/>
+          <p:nvPr/>
+        </p:nvSpPr>
+        <p:spPr>
+          <a:xfrm>
+            <a:off x="523951" y="3641141"/>
+            <a:ext cx="4270248" cy="228600"/>
+          </a:xfrm>
+          <a:prstGeom prst="rect">
+            <a:avLst/>
+          </a:prstGeom>
+          <a:noFill/>
+          <a:ln/>
+        </p:spPr>
+        <p:txBody>
+          <a:bodyPr wrap="none" lIns="0" tIns="0" rIns="0" bIns="0" rtlCol="0" anchor="ctr"/>
+          <a:lstStyle/>
+          <a:p>
+            <a:pPr indent="0" marL="0">
+              <a:buNone/>
+            </a:pPr>
+            <a:r>
+              <a:rPr lang="en-US" sz="1100" dirty="0">
+                <a:solidFill>
+                  <a:srgbClr val="F5F6FA"/>
+                </a:solidFill>
+                <a:latin typeface="Courier New" pitchFamily="34" charset="0"/>
+                <a:ea typeface="Courier New" pitchFamily="34" charset="-122"/>
+                <a:cs typeface="Courier New" pitchFamily="34" charset="-120"/>
+              </a:rPr>
+              <a:t>Digest: sha256:df221db836e1754089190208c…</a:t>
+            </a:r>
+            <a:endParaRPr lang="en-US" sz="1100" dirty="0"/>
+          </a:p>
+        </p:txBody>
+      </p:sp>
+      <p:sp>
+        <p:nvSpPr>
+          <p:cNvPr id="12" name="터미널줄5"/>
+          <p:cNvSpPr txBox="1"/>
+          <p:nvPr/>
+        </p:nvSpPr>
+        <p:spPr>
+          <a:xfrm>
+            <a:off x="523951" y="3869741"/>
+            <a:ext cx="4270248" cy="228600"/>
+          </a:xfrm>
+          <a:prstGeom prst="rect">
+            <a:avLst/>
+          </a:prstGeom>
+          <a:noFill/>
+          <a:ln/>
+        </p:spPr>
+        <p:txBody>
+          <a:bodyPr wrap="none" lIns="0" tIns="0" rIns="0" bIns="0" rtlCol="0" anchor="ctr"/>
+          <a:lstStyle/>
+          <a:p>
+            <a:pPr indent="0" marL="0">
+              <a:buNone/>
+            </a:pPr>
+            <a:r>
+              <a:rPr lang="en-US" sz="1100" dirty="0">
+                <a:solidFill>
+                  <a:srgbClr val="F5F6FA"/>
+                </a:solidFill>
+                <a:latin typeface="Courier New" pitchFamily="34" charset="0"/>
+                <a:ea typeface="Courier New" pitchFamily="34" charset="-122"/>
+                <a:cs typeface="Courier New" pitchFamily="34" charset="-120"/>
+              </a:rPr>
+              <a:t>Status: Downloaded newer image for nginx:alpine</a:t>
+            </a:r>
+            <a:endParaRPr lang="en-US" sz="1100" dirty="0"/>
+          </a:p>
+        </p:txBody>
+      </p:sp>
+      <p:sp>
+        <p:nvSpPr>
+          <p:cNvPr id="13" name="강조"/>
           <p:cNvSpPr/>
           <p:nvPr/>
         </p:nvSpPr>
         <p:spPr>
           <a:xfrm>
-            <a:off x="459943" y="3479597"/>
-            <a:ext cx="4398264" cy="284988"/>
+            <a:off x="459943" y="3860597"/>
+            <a:ext cx="4398264" cy="246888"/>
           </a:xfrm>
           <a:prstGeom prst="roundRect">
             <a:avLst>
-              <a:gd name="adj" fmla="val 16043"/>
+              <a:gd name="adj" fmla="val 18519"/>
             </a:avLst>
           </a:prstGeom>
           <a:solidFill>
@@ -3602,7 +5041,7 @@
       </p:sp>
       <p:sp>
         <p:nvSpPr>
-          <p:cNvPr id="12" name="설명라벨"/>
+          <p:cNvPr id="14" name="설명라벨"/>
           <p:cNvSpPr/>
           <p:nvPr/>
         </p:nvSpPr>
@@ -3629,7 +5068,7 @@
       </p:sp>
       <p:sp>
         <p:nvSpPr>
-          <p:cNvPr id="13" name="Text 10"/>
+          <p:cNvPr id="15" name="Text 12"/>
           <p:cNvSpPr txBox="1"/>
           <p:nvPr/>
         </p:nvSpPr>
@@ -3660,7 +5099,7 @@
                 <a:ea typeface="맑은 고딕" pitchFamily="34" charset="-122"/>
                 <a:cs typeface="맑은 고딕" pitchFamily="34" charset="-120"/>
               </a:rPr>
-              <a:t>이미지 목록: docker images</a:t>
+              <a:t>pull 실행 결과</a:t>
             </a:r>
             <a:endParaRPr lang="en-US" sz="1200" dirty="0"/>
           </a:p>
@@ -3770,7 +5209,7 @@
                 <a:ea typeface="맑은 고딕" pitchFamily="34" charset="-122"/>
                 <a:cs typeface="맑은 고딕" pitchFamily="34" charset="-120"/>
               </a:rPr>
-              <a:t>docker run으로 이미지를 컨테이너로 실행합니다. -d는 백그라운드, --name은 이름입니다.</a:t>
+              <a:t>docker images로 내려받은 이미지를 확인합니다.</a:t>
             </a:r>
             <a:endParaRPr lang="en-US" sz="1500" dirty="0"/>
           </a:p>
@@ -3878,7 +5317,7 @@
         <p:spPr>
           <a:xfrm>
             <a:off x="523951" y="2955341"/>
-            <a:ext cx="4270248" cy="228600"/>
+            <a:ext cx="4270248" cy="266700"/>
           </a:xfrm>
           <a:prstGeom prst="rect">
             <a:avLst/>
@@ -3894,7 +5333,7 @@
               <a:buNone/>
             </a:pPr>
             <a:r>
-              <a:rPr lang="en-US" sz="1100" b="1" dirty="0">
+              <a:rPr lang="en-US" sz="1300" b="1" dirty="0">
                 <a:solidFill>
                   <a:srgbClr val="50FA7B"/>
                 </a:solidFill>
@@ -3908,7 +5347,7 @@
               <a:buNone/>
             </a:pPr>
             <a:r>
-              <a:rPr lang="en-US" sz="1100" dirty="0">
+              <a:rPr lang="en-US" sz="1300" dirty="0">
                 <a:solidFill>
                   <a:srgbClr val="F5F6FA"/>
                 </a:solidFill>
@@ -3916,26 +5355,104 @@
                 <a:ea typeface="Courier New" pitchFamily="34" charset="-122"/>
                 <a:cs typeface="Courier New" pitchFamily="34" charset="-120"/>
               </a:rPr>
-              <a:t>docker run -d --name web nginx:alpine</a:t>
-            </a:r>
-            <a:endParaRPr lang="en-US" sz="1100" dirty="0"/>
-          </a:p>
-        </p:txBody>
-      </p:sp>
-      <p:sp>
-        <p:nvSpPr>
-          <p:cNvPr id="9" name="강조"/>
+              <a:t>docker images</a:t>
+            </a:r>
+            <a:endParaRPr lang="en-US" sz="1300" dirty="0"/>
+          </a:p>
+        </p:txBody>
+      </p:sp>
+      <p:sp>
+        <p:nvSpPr>
+          <p:cNvPr id="9" name="터미널줄2"/>
+          <p:cNvSpPr txBox="1"/>
+          <p:nvPr/>
+        </p:nvSpPr>
+        <p:spPr>
+          <a:xfrm>
+            <a:off x="523951" y="3222041"/>
+            <a:ext cx="4270248" cy="266700"/>
+          </a:xfrm>
+          <a:prstGeom prst="rect">
+            <a:avLst/>
+          </a:prstGeom>
+          <a:noFill/>
+          <a:ln/>
+        </p:spPr>
+        <p:txBody>
+          <a:bodyPr wrap="none" lIns="0" tIns="0" rIns="0" bIns="0" rtlCol="0" anchor="ctr"/>
+          <a:lstStyle/>
+          <a:p>
+            <a:pPr indent="0" marL="0">
+              <a:buNone/>
+            </a:pPr>
+            <a:r>
+              <a:rPr lang="en-US" sz="1300" dirty="0">
+                <a:solidFill>
+                  <a:srgbClr val="6B7280"/>
+                </a:solidFill>
+                <a:latin typeface="Courier New" pitchFamily="34" charset="0"/>
+                <a:ea typeface="Courier New" pitchFamily="34" charset="-122"/>
+                <a:cs typeface="Courier New" pitchFamily="34" charset="-120"/>
+              </a:rPr>
+              <a:t>IMAGE          ID             DISK USAGE</a:t>
+            </a:r>
+            <a:endParaRPr lang="en-US" sz="1300" dirty="0"/>
+          </a:p>
+        </p:txBody>
+      </p:sp>
+      <p:sp>
+        <p:nvSpPr>
+          <p:cNvPr id="10" name="터미널줄3"/>
+          <p:cNvSpPr txBox="1"/>
+          <p:nvPr/>
+        </p:nvSpPr>
+        <p:spPr>
+          <a:xfrm>
+            <a:off x="523951" y="3488741"/>
+            <a:ext cx="4270248" cy="266700"/>
+          </a:xfrm>
+          <a:prstGeom prst="rect">
+            <a:avLst/>
+          </a:prstGeom>
+          <a:noFill/>
+          <a:ln/>
+        </p:spPr>
+        <p:txBody>
+          <a:bodyPr wrap="none" lIns="0" tIns="0" rIns="0" bIns="0" rtlCol="0" anchor="ctr"/>
+          <a:lstStyle/>
+          <a:p>
+            <a:pPr indent="0" marL="0">
+              <a:buNone/>
+            </a:pPr>
+            <a:r>
+              <a:rPr lang="en-US" sz="1300" dirty="0">
+                <a:solidFill>
+                  <a:srgbClr val="F5F6FA"/>
+                </a:solidFill>
+                <a:latin typeface="Courier New" pitchFamily="34" charset="0"/>
+                <a:ea typeface="Courier New" pitchFamily="34" charset="-122"/>
+                <a:cs typeface="Courier New" pitchFamily="34" charset="-120"/>
+              </a:rPr>
+              <a:t>nginx:alpine   df221db836e1   94.4MB</a:t>
+            </a:r>
+            <a:endParaRPr lang="en-US" sz="1300" dirty="0"/>
+          </a:p>
+        </p:txBody>
+      </p:sp>
+      <p:sp>
+        <p:nvSpPr>
+          <p:cNvPr id="11" name="강조"/>
           <p:cNvSpPr/>
           <p:nvPr/>
         </p:nvSpPr>
         <p:spPr>
           <a:xfrm>
-            <a:off x="459943" y="2946197"/>
-            <a:ext cx="4398264" cy="246888"/>
+            <a:off x="459943" y="3479597"/>
+            <a:ext cx="4398264" cy="284988"/>
           </a:xfrm>
           <a:prstGeom prst="roundRect">
             <a:avLst>
-              <a:gd name="adj" fmla="val 18519"/>
+              <a:gd name="adj" fmla="val 16043"/>
             </a:avLst>
           </a:prstGeom>
           <a:solidFill>
@@ -3945,7 +5462,7 @@
           </a:solidFill>
           <a:ln w="22225">
             <a:solidFill>
-              <a:srgbClr val="FF79C6"/>
+              <a:srgbClr val="50FA7B"/>
             </a:solidFill>
             <a:prstDash val="solid"/>
           </a:ln>
@@ -3953,46 +5470,7 @@
       </p:sp>
       <p:sp>
         <p:nvSpPr>
-          <p:cNvPr id="10" name="터미널줄2"/>
-          <p:cNvSpPr txBox="1"/>
-          <p:nvPr/>
-        </p:nvSpPr>
-        <p:spPr>
-          <a:xfrm>
-            <a:off x="523951" y="3183941"/>
-            <a:ext cx="4270248" cy="228600"/>
-          </a:xfrm>
-          <a:prstGeom prst="rect">
-            <a:avLst/>
-          </a:prstGeom>
-          <a:noFill/>
-          <a:ln/>
-        </p:spPr>
-        <p:txBody>
-          <a:bodyPr wrap="none" lIns="0" tIns="0" rIns="0" bIns="0" rtlCol="0" anchor="ctr"/>
-          <a:lstStyle/>
-          <a:p>
-            <a:pPr indent="0" marL="0">
-              <a:buNone/>
-            </a:pPr>
-            <a:r>
-              <a:rPr lang="en-US" sz="1100" dirty="0">
-                <a:solidFill>
-                  <a:srgbClr val="F5F6FA"/>
-                </a:solidFill>
-                <a:latin typeface="Courier New" pitchFamily="34" charset="0"/>
-                <a:ea typeface="Courier New" pitchFamily="34" charset="-122"/>
-                <a:cs typeface="Courier New" pitchFamily="34" charset="-120"/>
-              </a:rPr>
-              <a:t>6f360068836a220770786a07896c5926b9db9288…</a:t>
-            </a:r>
-            <a:endParaRPr lang="en-US" sz="1100" dirty="0"/>
-          </a:p>
-        </p:txBody>
-      </p:sp>
-      <p:sp>
-        <p:nvSpPr>
-          <p:cNvPr id="11" name="설명라벨"/>
+          <p:cNvPr id="12" name="설명라벨"/>
           <p:cNvSpPr/>
           <p:nvPr/>
         </p:nvSpPr>
@@ -4007,11 +5485,11 @@
             </a:avLst>
           </a:prstGeom>
           <a:solidFill>
-            <a:srgbClr val="3B2F55"/>
+            <a:srgbClr val="24473A"/>
           </a:solidFill>
           <a:ln w="6350">
             <a:solidFill>
-              <a:srgbClr val="3B2F55"/>
+              <a:srgbClr val="24473A"/>
             </a:solidFill>
             <a:prstDash val="solid"/>
           </a:ln>
@@ -4019,7 +5497,7 @@
       </p:sp>
       <p:sp>
         <p:nvSpPr>
-          <p:cNvPr id="12" name="Text 9"/>
+          <p:cNvPr id="13" name="Text 10"/>
           <p:cNvSpPr txBox="1"/>
           <p:nvPr/>
         </p:nvSpPr>
@@ -4050,7 +5528,7 @@
                 <a:ea typeface="맑은 고딕" pitchFamily="34" charset="-122"/>
                 <a:cs typeface="맑은 고딕" pitchFamily="34" charset="-120"/>
               </a:rPr>
-              <a:t>컨테이너 실행: docker run</a:t>
+              <a:t>이미지 목록: docker images</a:t>
             </a:r>
             <a:endParaRPr lang="en-US" sz="1200" dirty="0"/>
           </a:p>
@@ -4160,7 +5638,7 @@
                 <a:ea typeface="맑은 고딕" pitchFamily="34" charset="-122"/>
                 <a:cs typeface="맑은 고딕" pitchFamily="34" charset="-120"/>
               </a:rPr>
-              <a:t>docker ps로 실행 중인 컨테이너를 확인합니다. Up이면 실행 중입니다.</a:t>
+              <a:t>docker run으로 이미지를 컨테이너로 실행합니다. -d는 백그라운드, --name은 이름입니다.</a:t>
             </a:r>
             <a:endParaRPr lang="en-US" sz="1500" dirty="0"/>
           </a:p>
@@ -4306,7 +5784,7 @@
                 <a:ea typeface="Courier New" pitchFamily="34" charset="-122"/>
                 <a:cs typeface="Courier New" pitchFamily="34" charset="-120"/>
               </a:rPr>
-              <a:t>docker ps</a:t>
+              <a:t>docker run -d --name web nginx:alpine</a:t>
             </a:r>
             <a:endParaRPr lang="en-US" sz="1100" dirty="0"/>
           </a:p>
@@ -4314,91 +5792,13 @@
       </p:sp>
       <p:sp>
         <p:nvSpPr>
-          <p:cNvPr id="9" name="터미널줄2"/>
-          <p:cNvSpPr txBox="1"/>
-          <p:nvPr/>
-        </p:nvSpPr>
-        <p:spPr>
-          <a:xfrm>
-            <a:off x="523951" y="3183941"/>
-            <a:ext cx="4270248" cy="228600"/>
-          </a:xfrm>
-          <a:prstGeom prst="rect">
-            <a:avLst/>
-          </a:prstGeom>
-          <a:noFill/>
-          <a:ln/>
-        </p:spPr>
-        <p:txBody>
-          <a:bodyPr wrap="none" lIns="0" tIns="0" rIns="0" bIns="0" rtlCol="0" anchor="ctr"/>
-          <a:lstStyle/>
-          <a:p>
-            <a:pPr indent="0" marL="0">
-              <a:buNone/>
-            </a:pPr>
-            <a:r>
-              <a:rPr lang="en-US" sz="1100" dirty="0">
-                <a:solidFill>
-                  <a:srgbClr val="6B7280"/>
-                </a:solidFill>
-                <a:latin typeface="Courier New" pitchFamily="34" charset="0"/>
-                <a:ea typeface="Courier New" pitchFamily="34" charset="-122"/>
-                <a:cs typeface="Courier New" pitchFamily="34" charset="-120"/>
-              </a:rPr>
-              <a:t>CONTAINER ID   IMAGE          STATUS         NAMES</a:t>
-            </a:r>
-            <a:endParaRPr lang="en-US" sz="1100" dirty="0"/>
-          </a:p>
-        </p:txBody>
-      </p:sp>
-      <p:sp>
-        <p:nvSpPr>
-          <p:cNvPr id="10" name="터미널줄3"/>
-          <p:cNvSpPr txBox="1"/>
-          <p:nvPr/>
-        </p:nvSpPr>
-        <p:spPr>
-          <a:xfrm>
-            <a:off x="523951" y="3412541"/>
-            <a:ext cx="4270248" cy="228600"/>
-          </a:xfrm>
-          <a:prstGeom prst="rect">
-            <a:avLst/>
-          </a:prstGeom>
-          <a:noFill/>
-          <a:ln/>
-        </p:spPr>
-        <p:txBody>
-          <a:bodyPr wrap="none" lIns="0" tIns="0" rIns="0" bIns="0" rtlCol="0" anchor="ctr"/>
-          <a:lstStyle/>
-          <a:p>
-            <a:pPr indent="0" marL="0">
-              <a:buNone/>
-            </a:pPr>
-            <a:r>
-              <a:rPr lang="en-US" sz="1100" dirty="0">
-                <a:solidFill>
-                  <a:srgbClr val="F5F6FA"/>
-                </a:solidFill>
-                <a:latin typeface="Courier New" pitchFamily="34" charset="0"/>
-                <a:ea typeface="Courier New" pitchFamily="34" charset="-122"/>
-                <a:cs typeface="Courier New" pitchFamily="34" charset="-120"/>
-              </a:rPr>
-              <a:t>6f360068836a   nginx:alpine   Up 3 seconds   web</a:t>
-            </a:r>
-            <a:endParaRPr lang="en-US" sz="1100" dirty="0"/>
-          </a:p>
-        </p:txBody>
-      </p:sp>
-      <p:sp>
-        <p:nvSpPr>
-          <p:cNvPr id="11" name="강조"/>
+          <p:cNvPr id="9" name="강조"/>
           <p:cNvSpPr/>
           <p:nvPr/>
         </p:nvSpPr>
         <p:spPr>
           <a:xfrm>
-            <a:off x="459943" y="3403397"/>
+            <a:off x="459943" y="2946197"/>
             <a:ext cx="4398264" cy="246888"/>
           </a:xfrm>
           <a:prstGeom prst="roundRect">
@@ -4413,7 +5813,7 @@
           </a:solidFill>
           <a:ln w="22225">
             <a:solidFill>
-              <a:srgbClr val="50FA7B"/>
+              <a:srgbClr val="FF79C6"/>
             </a:solidFill>
             <a:prstDash val="solid"/>
           </a:ln>
@@ -4421,7 +5821,46 @@
       </p:sp>
       <p:sp>
         <p:nvSpPr>
-          <p:cNvPr id="12" name="설명라벨"/>
+          <p:cNvPr id="10" name="터미널줄2"/>
+          <p:cNvSpPr txBox="1"/>
+          <p:nvPr/>
+        </p:nvSpPr>
+        <p:spPr>
+          <a:xfrm>
+            <a:off x="523951" y="3183941"/>
+            <a:ext cx="4270248" cy="228600"/>
+          </a:xfrm>
+          <a:prstGeom prst="rect">
+            <a:avLst/>
+          </a:prstGeom>
+          <a:noFill/>
+          <a:ln/>
+        </p:spPr>
+        <p:txBody>
+          <a:bodyPr wrap="none" lIns="0" tIns="0" rIns="0" bIns="0" rtlCol="0" anchor="ctr"/>
+          <a:lstStyle/>
+          <a:p>
+            <a:pPr indent="0" marL="0">
+              <a:buNone/>
+            </a:pPr>
+            <a:r>
+              <a:rPr lang="en-US" sz="1100" dirty="0">
+                <a:solidFill>
+                  <a:srgbClr val="F5F6FA"/>
+                </a:solidFill>
+                <a:latin typeface="Courier New" pitchFamily="34" charset="0"/>
+                <a:ea typeface="Courier New" pitchFamily="34" charset="-122"/>
+                <a:cs typeface="Courier New" pitchFamily="34" charset="-120"/>
+              </a:rPr>
+              <a:t>6f360068836a220770786a07896c5926b9db9288…</a:t>
+            </a:r>
+            <a:endParaRPr lang="en-US" sz="1100" dirty="0"/>
+          </a:p>
+        </p:txBody>
+      </p:sp>
+      <p:sp>
+        <p:nvSpPr>
+          <p:cNvPr id="11" name="설명라벨"/>
           <p:cNvSpPr/>
           <p:nvPr/>
         </p:nvSpPr>
@@ -4436,11 +5875,11 @@
             </a:avLst>
           </a:prstGeom>
           <a:solidFill>
-            <a:srgbClr val="24473A"/>
+            <a:srgbClr val="3B2F55"/>
           </a:solidFill>
           <a:ln w="6350">
             <a:solidFill>
-              <a:srgbClr val="24473A"/>
+              <a:srgbClr val="3B2F55"/>
             </a:solidFill>
             <a:prstDash val="solid"/>
           </a:ln>
@@ -4448,7 +5887,7 @@
       </p:sp>
       <p:sp>
         <p:nvSpPr>
-          <p:cNvPr id="13" name="Text 10"/>
+          <p:cNvPr id="12" name="Text 9"/>
           <p:cNvSpPr txBox="1"/>
           <p:nvPr/>
         </p:nvSpPr>
@@ -4479,7 +5918,7 @@
                 <a:ea typeface="맑은 고딕" pitchFamily="34" charset="-122"/>
                 <a:cs typeface="맑은 고딕" pitchFamily="34" charset="-120"/>
               </a:rPr>
-              <a:t>실행 중인 컨테이너: docker ps</a:t>
+              <a:t>컨테이너 실행: docker run</a:t>
             </a:r>
             <a:endParaRPr lang="en-US" sz="1200" dirty="0"/>
           </a:p>
@@ -4589,7 +6028,7 @@
                 <a:ea typeface="맑은 고딕" pitchFamily="34" charset="-122"/>
                 <a:cs typeface="맑은 고딕" pitchFamily="34" charset="-120"/>
               </a:rPr>
-              <a:t>같은 이미지로 컨테이너를 여러 개 실행할 수도 있습니다.</a:t>
+              <a:t>docker ps로 실행 중인 컨테이너를 확인합니다. Up이면 실행 중입니다.</a:t>
             </a:r>
             <a:endParaRPr lang="en-US" sz="1500" dirty="0"/>
           </a:p>
@@ -4735,7 +6174,7 @@
                 <a:ea typeface="Courier New" pitchFamily="34" charset="-122"/>
                 <a:cs typeface="Courier New" pitchFamily="34" charset="-120"/>
               </a:rPr>
-              <a:t>docker run -d --name web2 nginx:alpine</a:t>
+              <a:t>docker ps</a:t>
             </a:r>
             <a:endParaRPr lang="en-US" sz="1100" dirty="0"/>
           </a:p>
@@ -4743,13 +6182,91 @@
       </p:sp>
       <p:sp>
         <p:nvSpPr>
-          <p:cNvPr id="9" name="강조"/>
+          <p:cNvPr id="9" name="터미널줄2"/>
+          <p:cNvSpPr txBox="1"/>
+          <p:nvPr/>
+        </p:nvSpPr>
+        <p:spPr>
+          <a:xfrm>
+            <a:off x="523951" y="3183941"/>
+            <a:ext cx="4270248" cy="228600"/>
+          </a:xfrm>
+          <a:prstGeom prst="rect">
+            <a:avLst/>
+          </a:prstGeom>
+          <a:noFill/>
+          <a:ln/>
+        </p:spPr>
+        <p:txBody>
+          <a:bodyPr wrap="none" lIns="0" tIns="0" rIns="0" bIns="0" rtlCol="0" anchor="ctr"/>
+          <a:lstStyle/>
+          <a:p>
+            <a:pPr indent="0" marL="0">
+              <a:buNone/>
+            </a:pPr>
+            <a:r>
+              <a:rPr lang="en-US" sz="1100" dirty="0">
+                <a:solidFill>
+                  <a:srgbClr val="6B7280"/>
+                </a:solidFill>
+                <a:latin typeface="Courier New" pitchFamily="34" charset="0"/>
+                <a:ea typeface="Courier New" pitchFamily="34" charset="-122"/>
+                <a:cs typeface="Courier New" pitchFamily="34" charset="-120"/>
+              </a:rPr>
+              <a:t>CONTAINER ID   IMAGE          STATUS         NAMES</a:t>
+            </a:r>
+            <a:endParaRPr lang="en-US" sz="1100" dirty="0"/>
+          </a:p>
+        </p:txBody>
+      </p:sp>
+      <p:sp>
+        <p:nvSpPr>
+          <p:cNvPr id="10" name="터미널줄3"/>
+          <p:cNvSpPr txBox="1"/>
+          <p:nvPr/>
+        </p:nvSpPr>
+        <p:spPr>
+          <a:xfrm>
+            <a:off x="523951" y="3412541"/>
+            <a:ext cx="4270248" cy="228600"/>
+          </a:xfrm>
+          <a:prstGeom prst="rect">
+            <a:avLst/>
+          </a:prstGeom>
+          <a:noFill/>
+          <a:ln/>
+        </p:spPr>
+        <p:txBody>
+          <a:bodyPr wrap="none" lIns="0" tIns="0" rIns="0" bIns="0" rtlCol="0" anchor="ctr"/>
+          <a:lstStyle/>
+          <a:p>
+            <a:pPr indent="0" marL="0">
+              <a:buNone/>
+            </a:pPr>
+            <a:r>
+              <a:rPr lang="en-US" sz="1100" dirty="0">
+                <a:solidFill>
+                  <a:srgbClr val="F5F6FA"/>
+                </a:solidFill>
+                <a:latin typeface="Courier New" pitchFamily="34" charset="0"/>
+                <a:ea typeface="Courier New" pitchFamily="34" charset="-122"/>
+                <a:cs typeface="Courier New" pitchFamily="34" charset="-120"/>
+              </a:rPr>
+              <a:t>6f360068836a   nginx:alpine   Up 3 seconds   web</a:t>
+            </a:r>
+            <a:endParaRPr lang="en-US" sz="1100" dirty="0"/>
+          </a:p>
+        </p:txBody>
+      </p:sp>
+      <p:sp>
+        <p:nvSpPr>
+          <p:cNvPr id="11" name="강조"/>
           <p:cNvSpPr/>
           <p:nvPr/>
         </p:nvSpPr>
         <p:spPr>
           <a:xfrm>
-            <a:off x="459943" y="2946197"/>
+            <a:off x="459943" y="3403397"/>
             <a:ext cx="4398264" cy="246888"/>
           </a:xfrm>
           <a:prstGeom prst="roundRect">
@@ -4772,274 +6289,7 @@
       </p:sp>
       <p:sp>
         <p:nvSpPr>
-          <p:cNvPr id="10" name="터미널줄2"/>
-          <p:cNvSpPr txBox="1"/>
-          <p:nvPr/>
-        </p:nvSpPr>
-        <p:spPr>
-          <a:xfrm>
-            <a:off x="523951" y="3183941"/>
-            <a:ext cx="4270248" cy="228600"/>
-          </a:xfrm>
-          <a:prstGeom prst="rect">
-            <a:avLst/>
-          </a:prstGeom>
-          <a:noFill/>
-          <a:ln/>
-        </p:spPr>
-        <p:txBody>
-          <a:bodyPr wrap="none" lIns="0" tIns="0" rIns="0" bIns="0" rtlCol="0" anchor="ctr"/>
-          <a:lstStyle/>
-          <a:p>
-            <a:pPr indent="0" marL="0">
-              <a:buNone/>
-            </a:pPr>
-            <a:r>
-              <a:rPr lang="en-US" sz="1100" dirty="0">
-                <a:solidFill>
-                  <a:srgbClr val="F5F6FA"/>
-                </a:solidFill>
-                <a:latin typeface="Courier New" pitchFamily="34" charset="0"/>
-                <a:ea typeface="Courier New" pitchFamily="34" charset="-122"/>
-                <a:cs typeface="Courier New" pitchFamily="34" charset="-120"/>
-              </a:rPr>
-              <a:t>79e4073fcb973f64b85768bb15405ffc0b27c2b5…</a:t>
-            </a:r>
-            <a:endParaRPr lang="en-US" sz="1100" dirty="0"/>
-          </a:p>
-        </p:txBody>
-      </p:sp>
-      <p:sp>
-        <p:nvSpPr>
-          <p:cNvPr id="11" name="터미널줄3"/>
-          <p:cNvSpPr txBox="1"/>
-          <p:nvPr/>
-        </p:nvSpPr>
-        <p:spPr>
-          <a:xfrm>
-            <a:off x="523951" y="3412541"/>
-            <a:ext cx="4270248" cy="228600"/>
-          </a:xfrm>
-          <a:prstGeom prst="rect">
-            <a:avLst/>
-          </a:prstGeom>
-          <a:noFill/>
-          <a:ln/>
-        </p:spPr>
-        <p:txBody>
-          <a:bodyPr wrap="none" lIns="0" tIns="0" rIns="0" bIns="0" rtlCol="0" anchor="ctr"/>
-          <a:lstStyle/>
-          <a:p>
-            <a:pPr indent="0" marL="0">
-              <a:buNone/>
-            </a:pPr>
-            <a:r>
-              <a:rPr lang="en-US" sz="1100" b="1" dirty="0">
-                <a:solidFill>
-                  <a:srgbClr val="50FA7B"/>
-                </a:solidFill>
-                <a:latin typeface="Courier New" pitchFamily="34" charset="0"/>
-                <a:ea typeface="Courier New" pitchFamily="34" charset="-122"/>
-                <a:cs typeface="Courier New" pitchFamily="34" charset="-120"/>
-              </a:rPr>
-              <a:t>user@PC:~$ </a:t>
-            </a:r>
-            <a:pPr indent="0" marL="0">
-              <a:buNone/>
-            </a:pPr>
-            <a:r>
-              <a:rPr lang="en-US" sz="1100" dirty="0">
-                <a:solidFill>
-                  <a:srgbClr val="F5F6FA"/>
-                </a:solidFill>
-                <a:latin typeface="Courier New" pitchFamily="34" charset="0"/>
-                <a:ea typeface="Courier New" pitchFamily="34" charset="-122"/>
-                <a:cs typeface="Courier New" pitchFamily="34" charset="-120"/>
-              </a:rPr>
-              <a:t>docker ps</a:t>
-            </a:r>
-            <a:endParaRPr lang="en-US" sz="1100" dirty="0"/>
-          </a:p>
-        </p:txBody>
-      </p:sp>
-      <p:sp>
-        <p:nvSpPr>
-          <p:cNvPr id="12" name="터미널줄4"/>
-          <p:cNvSpPr txBox="1"/>
-          <p:nvPr/>
-        </p:nvSpPr>
-        <p:spPr>
-          <a:xfrm>
-            <a:off x="523951" y="3641141"/>
-            <a:ext cx="4270248" cy="228600"/>
-          </a:xfrm>
-          <a:prstGeom prst="rect">
-            <a:avLst/>
-          </a:prstGeom>
-          <a:noFill/>
-          <a:ln/>
-        </p:spPr>
-        <p:txBody>
-          <a:bodyPr wrap="none" lIns="0" tIns="0" rIns="0" bIns="0" rtlCol="0" anchor="ctr"/>
-          <a:lstStyle/>
-          <a:p>
-            <a:pPr indent="0" marL="0">
-              <a:buNone/>
-            </a:pPr>
-            <a:r>
-              <a:rPr lang="en-US" sz="1100" dirty="0">
-                <a:solidFill>
-                  <a:srgbClr val="6B7280"/>
-                </a:solidFill>
-                <a:latin typeface="Courier New" pitchFamily="34" charset="0"/>
-                <a:ea typeface="Courier New" pitchFamily="34" charset="-122"/>
-                <a:cs typeface="Courier New" pitchFamily="34" charset="-120"/>
-              </a:rPr>
-              <a:t>CONTAINER ID   IMAGE          STATUS         NAMES</a:t>
-            </a:r>
-            <a:endParaRPr lang="en-US" sz="1100" dirty="0"/>
-          </a:p>
-        </p:txBody>
-      </p:sp>
-      <p:sp>
-        <p:nvSpPr>
-          <p:cNvPr id="13" name="터미널줄5"/>
-          <p:cNvSpPr txBox="1"/>
-          <p:nvPr/>
-        </p:nvSpPr>
-        <p:spPr>
-          <a:xfrm>
-            <a:off x="523951" y="3869741"/>
-            <a:ext cx="4270248" cy="228600"/>
-          </a:xfrm>
-          <a:prstGeom prst="rect">
-            <a:avLst/>
-          </a:prstGeom>
-          <a:noFill/>
-          <a:ln/>
-        </p:spPr>
-        <p:txBody>
-          <a:bodyPr wrap="none" lIns="0" tIns="0" rIns="0" bIns="0" rtlCol="0" anchor="ctr"/>
-          <a:lstStyle/>
-          <a:p>
-            <a:pPr indent="0" marL="0">
-              <a:buNone/>
-            </a:pPr>
-            <a:r>
-              <a:rPr lang="en-US" sz="1100" dirty="0">
-                <a:solidFill>
-                  <a:srgbClr val="F5F6FA"/>
-                </a:solidFill>
-                <a:latin typeface="Courier New" pitchFamily="34" charset="0"/>
-                <a:ea typeface="Courier New" pitchFamily="34" charset="-122"/>
-                <a:cs typeface="Courier New" pitchFamily="34" charset="-120"/>
-              </a:rPr>
-              <a:t>79e4073fcb97   nginx:alpine   Up 2 seconds   web2</a:t>
-            </a:r>
-            <a:endParaRPr lang="en-US" sz="1100" dirty="0"/>
-          </a:p>
-        </p:txBody>
-      </p:sp>
-      <p:sp>
-        <p:nvSpPr>
-          <p:cNvPr id="14" name="강조"/>
-          <p:cNvSpPr/>
-          <p:nvPr/>
-        </p:nvSpPr>
-        <p:spPr>
-          <a:xfrm>
-            <a:off x="459943" y="3860597"/>
-            <a:ext cx="4398264" cy="246888"/>
-          </a:xfrm>
-          <a:prstGeom prst="roundRect">
-            <a:avLst>
-              <a:gd name="adj" fmla="val 18519"/>
-            </a:avLst>
-          </a:prstGeom>
-          <a:solidFill>
-            <a:srgbClr val="13141C">
-              <a:alpha val="0"/>
-            </a:srgbClr>
-          </a:solidFill>
-          <a:ln w="22225">
-            <a:solidFill>
-              <a:srgbClr val="50FA7B"/>
-            </a:solidFill>
-            <a:prstDash val="solid"/>
-          </a:ln>
-        </p:spPr>
-      </p:sp>
-      <p:sp>
-        <p:nvSpPr>
-          <p:cNvPr id="15" name="터미널줄6"/>
-          <p:cNvSpPr txBox="1"/>
-          <p:nvPr/>
-        </p:nvSpPr>
-        <p:spPr>
-          <a:xfrm>
-            <a:off x="523951" y="4098341"/>
-            <a:ext cx="4270248" cy="228600"/>
-          </a:xfrm>
-          <a:prstGeom prst="rect">
-            <a:avLst/>
-          </a:prstGeom>
-          <a:noFill/>
-          <a:ln/>
-        </p:spPr>
-        <p:txBody>
-          <a:bodyPr wrap="none" lIns="0" tIns="0" rIns="0" bIns="0" rtlCol="0" anchor="ctr"/>
-          <a:lstStyle/>
-          <a:p>
-            <a:pPr indent="0" marL="0">
-              <a:buNone/>
-            </a:pPr>
-            <a:r>
-              <a:rPr lang="en-US" sz="1100" dirty="0">
-                <a:solidFill>
-                  <a:srgbClr val="F5F6FA"/>
-                </a:solidFill>
-                <a:latin typeface="Courier New" pitchFamily="34" charset="0"/>
-                <a:ea typeface="Courier New" pitchFamily="34" charset="-122"/>
-                <a:cs typeface="Courier New" pitchFamily="34" charset="-120"/>
-              </a:rPr>
-              <a:t>6f360068836a   nginx:alpine   Up 5 seconds   web</a:t>
-            </a:r>
-            <a:endParaRPr lang="en-US" sz="1100" dirty="0"/>
-          </a:p>
-        </p:txBody>
-      </p:sp>
-      <p:sp>
-        <p:nvSpPr>
-          <p:cNvPr id="16" name="강조"/>
-          <p:cNvSpPr/>
-          <p:nvPr/>
-        </p:nvSpPr>
-        <p:spPr>
-          <a:xfrm>
-            <a:off x="459943" y="4089197"/>
-            <a:ext cx="4398264" cy="246888"/>
-          </a:xfrm>
-          <a:prstGeom prst="roundRect">
-            <a:avLst>
-              <a:gd name="adj" fmla="val 18519"/>
-            </a:avLst>
-          </a:prstGeom>
-          <a:solidFill>
-            <a:srgbClr val="13141C">
-              <a:alpha val="0"/>
-            </a:srgbClr>
-          </a:solidFill>
-          <a:ln w="22225">
-            <a:solidFill>
-              <a:srgbClr val="50FA7B"/>
-            </a:solidFill>
-            <a:prstDash val="solid"/>
-          </a:ln>
-        </p:spPr>
-      </p:sp>
-      <p:sp>
-        <p:nvSpPr>
-          <p:cNvPr id="17" name="설명라벨"/>
+          <p:cNvPr id="12" name="설명라벨"/>
           <p:cNvSpPr/>
           <p:nvPr/>
         </p:nvSpPr>
@@ -5066,7 +6316,7 @@
       </p:sp>
       <p:sp>
         <p:nvSpPr>
-          <p:cNvPr id="18" name="Text 15"/>
+          <p:cNvPr id="13" name="Text 10"/>
           <p:cNvSpPr txBox="1"/>
           <p:nvPr/>
         </p:nvSpPr>
@@ -5097,7 +6347,7 @@
                 <a:ea typeface="맑은 고딕" pitchFamily="34" charset="-122"/>
                 <a:cs typeface="맑은 고딕" pitchFamily="34" charset="-120"/>
               </a:rPr>
-              <a:t>이미지 하나, 컨테이너 둘</a:t>
+              <a:t>실행 중인 컨테이너: docker ps</a:t>
             </a:r>
             <a:endParaRPr lang="en-US" sz="1200" dirty="0"/>
           </a:p>
@@ -5207,7 +6457,7 @@
                 <a:ea typeface="맑은 고딕" pitchFamily="34" charset="-122"/>
                 <a:cs typeface="맑은 고딕" pitchFamily="34" charset="-120"/>
               </a:rPr>
-              <a:t>pull로 받고, images로 확인하고, run으로 실행하고, ps로 확인합니다.</a:t>
+              <a:t>NAMES 열에서 컨테이너 이름을 확인할 수 있습니다.</a:t>
             </a:r>
             <a:endParaRPr lang="en-US" sz="1500" dirty="0"/>
           </a:p>
@@ -5215,18 +6465,18 @@
       </p:sp>
       <p:sp>
         <p:nvSpPr>
-          <p:cNvPr id="5" name="요약행1"/>
+          <p:cNvPr id="5" name="터미널탭"/>
           <p:cNvSpPr/>
           <p:nvPr/>
         </p:nvSpPr>
         <p:spPr>
           <a:xfrm>
-            <a:off x="411480" y="2377440"/>
-            <a:ext cx="4297680" cy="731520"/>
+            <a:off x="395935" y="2404872"/>
+            <a:ext cx="1542593" cy="319126"/>
           </a:xfrm>
           <a:prstGeom prst="roundRect">
             <a:avLst>
-              <a:gd name="adj" fmla="val 12500"/>
+              <a:gd name="adj" fmla="val 17192"/>
             </a:avLst>
           </a:prstGeom>
           <a:solidFill>
@@ -5248,8 +6498,8 @@
         </p:nvSpPr>
         <p:spPr>
           <a:xfrm>
-            <a:off x="548640" y="2377440"/>
-            <a:ext cx="1920240" cy="731520"/>
+            <a:off x="395935" y="2404872"/>
+            <a:ext cx="1542593" cy="319126"/>
           </a:xfrm>
           <a:prstGeom prst="rect">
             <a:avLst/>
@@ -5261,77 +6511,38 @@
           <a:bodyPr wrap="square" lIns="0" tIns="0" rIns="0" bIns="0" rtlCol="0" anchor="ctr"/>
           <a:lstStyle/>
           <a:p>
-            <a:pPr indent="0" marL="0">
-              <a:buNone/>
-            </a:pPr>
-            <a:r>
-              <a:rPr lang="en-US" sz="1300" b="1" dirty="0">
-                <a:solidFill>
-                  <a:srgbClr val="FF79C6"/>
+            <a:pPr algn="ctr" indent="0" marL="0">
+              <a:buNone/>
+            </a:pPr>
+            <a:r>
+              <a:rPr lang="en-US" sz="1125" b="1" dirty="0">
+                <a:solidFill>
+                  <a:srgbClr val="F5F6FA"/>
                 </a:solidFill>
                 <a:latin typeface="Courier New" pitchFamily="34" charset="0"/>
                 <a:ea typeface="Courier New" pitchFamily="34" charset="-122"/>
                 <a:cs typeface="Courier New" pitchFamily="34" charset="-120"/>
               </a:rPr>
-              <a:t>docker pull</a:t>
-            </a:r>
-            <a:endParaRPr lang="en-US" sz="1300" dirty="0"/>
-          </a:p>
-        </p:txBody>
-      </p:sp>
-      <p:sp>
-        <p:nvSpPr>
-          <p:cNvPr id="7" name="Text 4"/>
-          <p:cNvSpPr txBox="1"/>
-          <p:nvPr/>
-        </p:nvSpPr>
-        <p:spPr>
-          <a:xfrm>
-            <a:off x="2423160" y="2377440"/>
-            <a:ext cx="2194560" cy="731520"/>
-          </a:xfrm>
-          <a:prstGeom prst="rect">
-            <a:avLst/>
-          </a:prstGeom>
-          <a:noFill/>
-          <a:ln/>
-        </p:spPr>
-        <p:txBody>
-          <a:bodyPr wrap="square" lIns="0" tIns="0" rIns="0" bIns="0" rtlCol="0" anchor="ctr"/>
-          <a:lstStyle/>
-          <a:p>
-            <a:pPr indent="0" marL="0">
-              <a:buNone/>
-            </a:pPr>
-            <a:r>
-              <a:rPr lang="en-US" sz="1400" dirty="0">
-                <a:solidFill>
-                  <a:srgbClr val="F5F6FA"/>
-                </a:solidFill>
-                <a:latin typeface="맑은 고딕" pitchFamily="34" charset="0"/>
-                <a:ea typeface="맑은 고딕" pitchFamily="34" charset="-122"/>
-                <a:cs typeface="맑은 고딕" pitchFamily="34" charset="-120"/>
-              </a:rPr>
-              <a:t>이미지 내려받기</a:t>
-            </a:r>
-            <a:endParaRPr lang="en-US" sz="1400" dirty="0"/>
-          </a:p>
-        </p:txBody>
-      </p:sp>
-      <p:sp>
-        <p:nvSpPr>
-          <p:cNvPr id="8" name="요약행2"/>
+              <a:t>terminal</a:t>
+            </a:r>
+            <a:endParaRPr lang="en-US" sz="1125" dirty="0"/>
+          </a:p>
+        </p:txBody>
+      </p:sp>
+      <p:sp>
+        <p:nvSpPr>
+          <p:cNvPr id="7" name="터미널박스"/>
           <p:cNvSpPr/>
           <p:nvPr/>
         </p:nvSpPr>
         <p:spPr>
           <a:xfrm>
-            <a:off x="411480" y="3246120"/>
-            <a:ext cx="4297680" cy="731520"/>
+            <a:off x="395935" y="2827325"/>
+            <a:ext cx="4526280" cy="2124151"/>
           </a:xfrm>
           <a:prstGeom prst="roundRect">
             <a:avLst>
-              <a:gd name="adj" fmla="val 12500"/>
+              <a:gd name="adj" fmla="val 3444"/>
             </a:avLst>
           </a:prstGeom>
           <a:solidFill>
@@ -5347,53 +6558,230 @@
       </p:sp>
       <p:sp>
         <p:nvSpPr>
-          <p:cNvPr id="9" name="Text 6"/>
-          <p:cNvSpPr txBox="1"/>
-          <p:nvPr/>
-        </p:nvSpPr>
-        <p:spPr>
-          <a:xfrm>
-            <a:off x="548640" y="3246120"/>
-            <a:ext cx="1920240" cy="731520"/>
-          </a:xfrm>
-          <a:prstGeom prst="rect">
-            <a:avLst/>
-          </a:prstGeom>
-          <a:noFill/>
-          <a:ln/>
-        </p:spPr>
-        <p:txBody>
-          <a:bodyPr wrap="square" lIns="0" tIns="0" rIns="0" bIns="0" rtlCol="0" anchor="ctr"/>
+          <p:cNvPr id="8" name="터미널줄1"/>
+          <p:cNvSpPr txBox="1"/>
+          <p:nvPr/>
+        </p:nvSpPr>
+        <p:spPr>
+          <a:xfrm>
+            <a:off x="523951" y="2955341"/>
+            <a:ext cx="4270248" cy="228600"/>
+          </a:xfrm>
+          <a:prstGeom prst="rect">
+            <a:avLst/>
+          </a:prstGeom>
+          <a:noFill/>
+          <a:ln/>
+        </p:spPr>
+        <p:txBody>
+          <a:bodyPr wrap="none" lIns="0" tIns="0" rIns="0" bIns="0" rtlCol="0" anchor="ctr"/>
           <a:lstStyle/>
           <a:p>
             <a:pPr indent="0" marL="0">
               <a:buNone/>
             </a:pPr>
             <a:r>
-              <a:rPr lang="en-US" sz="1300" b="1" dirty="0">
-                <a:solidFill>
-                  <a:srgbClr val="FF79C6"/>
+              <a:rPr lang="en-US" sz="1100" b="1" dirty="0">
+                <a:solidFill>
+                  <a:srgbClr val="50FA7B"/>
                 </a:solidFill>
                 <a:latin typeface="Courier New" pitchFamily="34" charset="0"/>
                 <a:ea typeface="Courier New" pitchFamily="34" charset="-122"/>
                 <a:cs typeface="Courier New" pitchFamily="34" charset="-120"/>
               </a:rPr>
-              <a:t>docker images</a:t>
-            </a:r>
-            <a:endParaRPr lang="en-US" sz="1300" dirty="0"/>
-          </a:p>
-        </p:txBody>
-      </p:sp>
-      <p:sp>
-        <p:nvSpPr>
-          <p:cNvPr id="10" name="Text 7"/>
-          <p:cNvSpPr txBox="1"/>
-          <p:nvPr/>
-        </p:nvSpPr>
-        <p:spPr>
-          <a:xfrm>
-            <a:off x="2423160" y="3246120"/>
-            <a:ext cx="2194560" cy="731520"/>
+              <a:t>user@PC:~$ </a:t>
+            </a:r>
+            <a:pPr indent="0" marL="0">
+              <a:buNone/>
+            </a:pPr>
+            <a:r>
+              <a:rPr lang="en-US" sz="1100" dirty="0">
+                <a:solidFill>
+                  <a:srgbClr val="F5F6FA"/>
+                </a:solidFill>
+                <a:latin typeface="Courier New" pitchFamily="34" charset="0"/>
+                <a:ea typeface="Courier New" pitchFamily="34" charset="-122"/>
+                <a:cs typeface="Courier New" pitchFamily="34" charset="-120"/>
+              </a:rPr>
+              <a:t>docker ps</a:t>
+            </a:r>
+            <a:endParaRPr lang="en-US" sz="1100" dirty="0"/>
+          </a:p>
+        </p:txBody>
+      </p:sp>
+      <p:sp>
+        <p:nvSpPr>
+          <p:cNvPr id="9" name="터미널줄2"/>
+          <p:cNvSpPr txBox="1"/>
+          <p:nvPr/>
+        </p:nvSpPr>
+        <p:spPr>
+          <a:xfrm>
+            <a:off x="523951" y="3183941"/>
+            <a:ext cx="4270248" cy="228600"/>
+          </a:xfrm>
+          <a:prstGeom prst="rect">
+            <a:avLst/>
+          </a:prstGeom>
+          <a:noFill/>
+          <a:ln/>
+        </p:spPr>
+        <p:txBody>
+          <a:bodyPr wrap="none" lIns="0" tIns="0" rIns="0" bIns="0" rtlCol="0" anchor="ctr"/>
+          <a:lstStyle/>
+          <a:p>
+            <a:pPr indent="0" marL="0">
+              <a:buNone/>
+            </a:pPr>
+            <a:r>
+              <a:rPr lang="en-US" sz="1100" dirty="0">
+                <a:solidFill>
+                  <a:srgbClr val="6B7280"/>
+                </a:solidFill>
+                <a:latin typeface="Courier New" pitchFamily="34" charset="0"/>
+                <a:ea typeface="Courier New" pitchFamily="34" charset="-122"/>
+                <a:cs typeface="Courier New" pitchFamily="34" charset="-120"/>
+              </a:rPr>
+              <a:t>CONTAINER ID   IMAGE          STATUS         NAMES</a:t>
+            </a:r>
+            <a:endParaRPr lang="en-US" sz="1100" dirty="0"/>
+          </a:p>
+        </p:txBody>
+      </p:sp>
+      <p:sp>
+        <p:nvSpPr>
+          <p:cNvPr id="10" name="강조열"/>
+          <p:cNvSpPr/>
+          <p:nvPr/>
+        </p:nvSpPr>
+        <p:spPr>
+          <a:xfrm>
+            <a:off x="4250131" y="3174797"/>
+            <a:ext cx="510540" cy="246888"/>
+          </a:xfrm>
+          <a:prstGeom prst="roundRect">
+            <a:avLst>
+              <a:gd name="adj" fmla="val 18519"/>
+            </a:avLst>
+          </a:prstGeom>
+          <a:solidFill>
+            <a:srgbClr val="13141C">
+              <a:alpha val="0"/>
+            </a:srgbClr>
+          </a:solidFill>
+          <a:ln w="22225">
+            <a:solidFill>
+              <a:srgbClr val="50FA7B"/>
+            </a:solidFill>
+            <a:prstDash val="solid"/>
+          </a:ln>
+        </p:spPr>
+      </p:sp>
+      <p:sp>
+        <p:nvSpPr>
+          <p:cNvPr id="11" name="터미널줄3"/>
+          <p:cNvSpPr txBox="1"/>
+          <p:nvPr/>
+        </p:nvSpPr>
+        <p:spPr>
+          <a:xfrm>
+            <a:off x="523951" y="3412541"/>
+            <a:ext cx="4270248" cy="228600"/>
+          </a:xfrm>
+          <a:prstGeom prst="rect">
+            <a:avLst/>
+          </a:prstGeom>
+          <a:noFill/>
+          <a:ln/>
+        </p:spPr>
+        <p:txBody>
+          <a:bodyPr wrap="none" lIns="0" tIns="0" rIns="0" bIns="0" rtlCol="0" anchor="ctr"/>
+          <a:lstStyle/>
+          <a:p>
+            <a:pPr indent="0" marL="0">
+              <a:buNone/>
+            </a:pPr>
+            <a:r>
+              <a:rPr lang="en-US" sz="1100" dirty="0">
+                <a:solidFill>
+                  <a:srgbClr val="F5F6FA"/>
+                </a:solidFill>
+                <a:latin typeface="Courier New" pitchFamily="34" charset="0"/>
+                <a:ea typeface="Courier New" pitchFamily="34" charset="-122"/>
+                <a:cs typeface="Courier New" pitchFamily="34" charset="-120"/>
+              </a:rPr>
+              <a:t>6f360068836a   nginx:alpine   Up 3 seconds   web</a:t>
+            </a:r>
+            <a:endParaRPr lang="en-US" sz="1100" dirty="0"/>
+          </a:p>
+        </p:txBody>
+      </p:sp>
+      <p:sp>
+        <p:nvSpPr>
+          <p:cNvPr id="12" name="강조열"/>
+          <p:cNvSpPr/>
+          <p:nvPr/>
+        </p:nvSpPr>
+        <p:spPr>
+          <a:xfrm>
+            <a:off x="4250131" y="3403397"/>
+            <a:ext cx="342900" cy="246888"/>
+          </a:xfrm>
+          <a:prstGeom prst="roundRect">
+            <a:avLst>
+              <a:gd name="adj" fmla="val 18519"/>
+            </a:avLst>
+          </a:prstGeom>
+          <a:solidFill>
+            <a:srgbClr val="13141C">
+              <a:alpha val="0"/>
+            </a:srgbClr>
+          </a:solidFill>
+          <a:ln w="22225">
+            <a:solidFill>
+              <a:srgbClr val="50FA7B"/>
+            </a:solidFill>
+            <a:prstDash val="solid"/>
+          </a:ln>
+        </p:spPr>
+      </p:sp>
+      <p:sp>
+        <p:nvSpPr>
+          <p:cNvPr id="13" name="설명라벨"/>
+          <p:cNvSpPr/>
+          <p:nvPr/>
+        </p:nvSpPr>
+        <p:spPr>
+          <a:xfrm>
+            <a:off x="395935" y="5157216"/>
+            <a:ext cx="4526280" cy="384048"/>
+          </a:xfrm>
+          <a:prstGeom prst="roundRect">
+            <a:avLst>
+              <a:gd name="adj" fmla="val 14286"/>
+            </a:avLst>
+          </a:prstGeom>
+          <a:solidFill>
+            <a:srgbClr val="24473A"/>
+          </a:solidFill>
+          <a:ln w="6350">
+            <a:solidFill>
+              <a:srgbClr val="24473A"/>
+            </a:solidFill>
+            <a:prstDash val="solid"/>
+          </a:ln>
+        </p:spPr>
+      </p:sp>
+      <p:sp>
+        <p:nvSpPr>
+          <p:cNvPr id="14" name="Text 11"/>
+          <p:cNvSpPr txBox="1"/>
+          <p:nvPr/>
+        </p:nvSpPr>
+        <p:spPr>
+          <a:xfrm>
+            <a:off x="395935" y="5157216"/>
+            <a:ext cx="4526280" cy="384048"/>
           </a:xfrm>
           <a:prstGeom prst="rect">
             <a:avLst/>
@@ -5405,11 +6793,11 @@
           <a:bodyPr wrap="square" lIns="0" tIns="0" rIns="0" bIns="0" rtlCol="0" anchor="ctr"/>
           <a:lstStyle/>
           <a:p>
-            <a:pPr indent="0" marL="0">
-              <a:buNone/>
-            </a:pPr>
-            <a:r>
-              <a:rPr lang="en-US" sz="1400" dirty="0">
+            <a:pPr algn="ctr" indent="0" marL="0">
+              <a:buNone/>
+            </a:pPr>
+            <a:r>
+              <a:rPr lang="en-US" sz="1200" b="1" dirty="0">
                 <a:solidFill>
                   <a:srgbClr val="F5F6FA"/>
                 </a:solidFill>
@@ -5417,219 +6805,9 @@
                 <a:ea typeface="맑은 고딕" pitchFamily="34" charset="-122"/>
                 <a:cs typeface="맑은 고딕" pitchFamily="34" charset="-120"/>
               </a:rPr>
-              <a:t>이미지 목록 보기</a:t>
-            </a:r>
-            <a:endParaRPr lang="en-US" sz="1400" dirty="0"/>
-          </a:p>
-        </p:txBody>
-      </p:sp>
-      <p:sp>
-        <p:nvSpPr>
-          <p:cNvPr id="11" name="요약행3"/>
-          <p:cNvSpPr/>
-          <p:nvPr/>
-        </p:nvSpPr>
-        <p:spPr>
-          <a:xfrm>
-            <a:off x="411480" y="4114800"/>
-            <a:ext cx="4297680" cy="731520"/>
-          </a:xfrm>
-          <a:prstGeom prst="roundRect">
-            <a:avLst>
-              <a:gd name="adj" fmla="val 12500"/>
-            </a:avLst>
-          </a:prstGeom>
-          <a:solidFill>
-            <a:srgbClr val="13141C"/>
-          </a:solidFill>
-          <a:ln w="9525">
-            <a:solidFill>
-              <a:srgbClr val="393B4A"/>
-            </a:solidFill>
-            <a:prstDash val="solid"/>
-          </a:ln>
-        </p:spPr>
-      </p:sp>
-      <p:sp>
-        <p:nvSpPr>
-          <p:cNvPr id="12" name="Text 9"/>
-          <p:cNvSpPr txBox="1"/>
-          <p:nvPr/>
-        </p:nvSpPr>
-        <p:spPr>
-          <a:xfrm>
-            <a:off x="548640" y="4114800"/>
-            <a:ext cx="1920240" cy="731520"/>
-          </a:xfrm>
-          <a:prstGeom prst="rect">
-            <a:avLst/>
-          </a:prstGeom>
-          <a:noFill/>
-          <a:ln/>
-        </p:spPr>
-        <p:txBody>
-          <a:bodyPr wrap="square" lIns="0" tIns="0" rIns="0" bIns="0" rtlCol="0" anchor="ctr"/>
-          <a:lstStyle/>
-          <a:p>
-            <a:pPr indent="0" marL="0">
-              <a:buNone/>
-            </a:pPr>
-            <a:r>
-              <a:rPr lang="en-US" sz="1300" b="1" dirty="0">
-                <a:solidFill>
-                  <a:srgbClr val="FF79C6"/>
-                </a:solidFill>
-                <a:latin typeface="Courier New" pitchFamily="34" charset="0"/>
-                <a:ea typeface="Courier New" pitchFamily="34" charset="-122"/>
-                <a:cs typeface="Courier New" pitchFamily="34" charset="-120"/>
-              </a:rPr>
-              <a:t>docker run</a:t>
-            </a:r>
-            <a:endParaRPr lang="en-US" sz="1300" dirty="0"/>
-          </a:p>
-        </p:txBody>
-      </p:sp>
-      <p:sp>
-        <p:nvSpPr>
-          <p:cNvPr id="13" name="Text 10"/>
-          <p:cNvSpPr txBox="1"/>
-          <p:nvPr/>
-        </p:nvSpPr>
-        <p:spPr>
-          <a:xfrm>
-            <a:off x="2423160" y="4114800"/>
-            <a:ext cx="2194560" cy="731520"/>
-          </a:xfrm>
-          <a:prstGeom prst="rect">
-            <a:avLst/>
-          </a:prstGeom>
-          <a:noFill/>
-          <a:ln/>
-        </p:spPr>
-        <p:txBody>
-          <a:bodyPr wrap="square" lIns="0" tIns="0" rIns="0" bIns="0" rtlCol="0" anchor="ctr"/>
-          <a:lstStyle/>
-          <a:p>
-            <a:pPr indent="0" marL="0">
-              <a:buNone/>
-            </a:pPr>
-            <a:r>
-              <a:rPr lang="en-US" sz="1400" dirty="0">
-                <a:solidFill>
-                  <a:srgbClr val="F5F6FA"/>
-                </a:solidFill>
-                <a:latin typeface="맑은 고딕" pitchFamily="34" charset="0"/>
-                <a:ea typeface="맑은 고딕" pitchFamily="34" charset="-122"/>
-                <a:cs typeface="맑은 고딕" pitchFamily="34" charset="-120"/>
-              </a:rPr>
-              <a:t>컨테이너 실행</a:t>
-            </a:r>
-            <a:endParaRPr lang="en-US" sz="1400" dirty="0"/>
-          </a:p>
-        </p:txBody>
-      </p:sp>
-      <p:sp>
-        <p:nvSpPr>
-          <p:cNvPr id="14" name="요약행4"/>
-          <p:cNvSpPr/>
-          <p:nvPr/>
-        </p:nvSpPr>
-        <p:spPr>
-          <a:xfrm>
-            <a:off x="411480" y="4983480"/>
-            <a:ext cx="4297680" cy="731520"/>
-          </a:xfrm>
-          <a:prstGeom prst="roundRect">
-            <a:avLst>
-              <a:gd name="adj" fmla="val 12500"/>
-            </a:avLst>
-          </a:prstGeom>
-          <a:solidFill>
-            <a:srgbClr val="13141C"/>
-          </a:solidFill>
-          <a:ln w="9525">
-            <a:solidFill>
-              <a:srgbClr val="393B4A"/>
-            </a:solidFill>
-            <a:prstDash val="solid"/>
-          </a:ln>
-        </p:spPr>
-      </p:sp>
-      <p:sp>
-        <p:nvSpPr>
-          <p:cNvPr id="15" name="Text 12"/>
-          <p:cNvSpPr txBox="1"/>
-          <p:nvPr/>
-        </p:nvSpPr>
-        <p:spPr>
-          <a:xfrm>
-            <a:off x="548640" y="4983480"/>
-            <a:ext cx="1920240" cy="731520"/>
-          </a:xfrm>
-          <a:prstGeom prst="rect">
-            <a:avLst/>
-          </a:prstGeom>
-          <a:noFill/>
-          <a:ln/>
-        </p:spPr>
-        <p:txBody>
-          <a:bodyPr wrap="square" lIns="0" tIns="0" rIns="0" bIns="0" rtlCol="0" anchor="ctr"/>
-          <a:lstStyle/>
-          <a:p>
-            <a:pPr indent="0" marL="0">
-              <a:buNone/>
-            </a:pPr>
-            <a:r>
-              <a:rPr lang="en-US" sz="1300" b="1" dirty="0">
-                <a:solidFill>
-                  <a:srgbClr val="FF79C6"/>
-                </a:solidFill>
-                <a:latin typeface="Courier New" pitchFamily="34" charset="0"/>
-                <a:ea typeface="Courier New" pitchFamily="34" charset="-122"/>
-                <a:cs typeface="Courier New" pitchFamily="34" charset="-120"/>
-              </a:rPr>
-              <a:t>docker ps</a:t>
-            </a:r>
-            <a:endParaRPr lang="en-US" sz="1300" dirty="0"/>
-          </a:p>
-        </p:txBody>
-      </p:sp>
-      <p:sp>
-        <p:nvSpPr>
-          <p:cNvPr id="16" name="Text 13"/>
-          <p:cNvSpPr txBox="1"/>
-          <p:nvPr/>
-        </p:nvSpPr>
-        <p:spPr>
-          <a:xfrm>
-            <a:off x="2423160" y="4983480"/>
-            <a:ext cx="2194560" cy="731520"/>
-          </a:xfrm>
-          <a:prstGeom prst="rect">
-            <a:avLst/>
-          </a:prstGeom>
-          <a:noFill/>
-          <a:ln/>
-        </p:spPr>
-        <p:txBody>
-          <a:bodyPr wrap="square" lIns="0" tIns="0" rIns="0" bIns="0" rtlCol="0" anchor="ctr"/>
-          <a:lstStyle/>
-          <a:p>
-            <a:pPr indent="0" marL="0">
-              <a:buNone/>
-            </a:pPr>
-            <a:r>
-              <a:rPr lang="en-US" sz="1400" dirty="0">
-                <a:solidFill>
-                  <a:srgbClr val="F5F6FA"/>
-                </a:solidFill>
-                <a:latin typeface="맑은 고딕" pitchFamily="34" charset="0"/>
-                <a:ea typeface="맑은 고딕" pitchFamily="34" charset="-122"/>
-                <a:cs typeface="맑은 고딕" pitchFamily="34" charset="-120"/>
-              </a:rPr>
-              <a:t>실행 중인 컨테이너 보기</a:t>
-            </a:r>
-            <a:endParaRPr lang="en-US" sz="1400" dirty="0"/>
+              <a:t>컨테이너 이름: NAMES</a:t>
+            </a:r>
+            <a:endParaRPr lang="en-US" sz="1200" dirty="0"/>
           </a:p>
         </p:txBody>
       </p:sp>

</xml_diff>